<commit_message>
Updates graph architecture slides
</commit_message>
<xml_diff>
--- a/graph_architecture.pptx
+++ b/graph_architecture.pptx
@@ -259,7 +259,7 @@
           <a:p>
             <a:fld id="{2D8659F3-DB80-4E75-82CE-949E02E89EB1}" type="datetimeFigureOut">
               <a:rPr lang="en-US" smtClean="0"/>
-              <a:t>4/4/2025</a:t>
+              <a:t>4/30/2025</a:t>
             </a:fld>
             <a:endParaRPr lang="en-US"/>
           </a:p>
@@ -457,7 +457,7 @@
           <a:p>
             <a:fld id="{2D8659F3-DB80-4E75-82CE-949E02E89EB1}" type="datetimeFigureOut">
               <a:rPr lang="en-US" smtClean="0"/>
-              <a:t>4/4/2025</a:t>
+              <a:t>4/30/2025</a:t>
             </a:fld>
             <a:endParaRPr lang="en-US"/>
           </a:p>
@@ -665,7 +665,7 @@
           <a:p>
             <a:fld id="{2D8659F3-DB80-4E75-82CE-949E02E89EB1}" type="datetimeFigureOut">
               <a:rPr lang="en-US" smtClean="0"/>
-              <a:t>4/4/2025</a:t>
+              <a:t>4/30/2025</a:t>
             </a:fld>
             <a:endParaRPr lang="en-US"/>
           </a:p>
@@ -863,7 +863,7 @@
           <a:p>
             <a:fld id="{2D8659F3-DB80-4E75-82CE-949E02E89EB1}" type="datetimeFigureOut">
               <a:rPr lang="en-US" smtClean="0"/>
-              <a:t>4/4/2025</a:t>
+              <a:t>4/30/2025</a:t>
             </a:fld>
             <a:endParaRPr lang="en-US"/>
           </a:p>
@@ -1138,7 +1138,7 @@
           <a:p>
             <a:fld id="{2D8659F3-DB80-4E75-82CE-949E02E89EB1}" type="datetimeFigureOut">
               <a:rPr lang="en-US" smtClean="0"/>
-              <a:t>4/4/2025</a:t>
+              <a:t>4/30/2025</a:t>
             </a:fld>
             <a:endParaRPr lang="en-US"/>
           </a:p>
@@ -1403,7 +1403,7 @@
           <a:p>
             <a:fld id="{2D8659F3-DB80-4E75-82CE-949E02E89EB1}" type="datetimeFigureOut">
               <a:rPr lang="en-US" smtClean="0"/>
-              <a:t>4/4/2025</a:t>
+              <a:t>4/30/2025</a:t>
             </a:fld>
             <a:endParaRPr lang="en-US"/>
           </a:p>
@@ -1815,7 +1815,7 @@
           <a:p>
             <a:fld id="{2D8659F3-DB80-4E75-82CE-949E02E89EB1}" type="datetimeFigureOut">
               <a:rPr lang="en-US" smtClean="0"/>
-              <a:t>4/4/2025</a:t>
+              <a:t>4/30/2025</a:t>
             </a:fld>
             <a:endParaRPr lang="en-US"/>
           </a:p>
@@ -1956,7 +1956,7 @@
           <a:p>
             <a:fld id="{2D8659F3-DB80-4E75-82CE-949E02E89EB1}" type="datetimeFigureOut">
               <a:rPr lang="en-US" smtClean="0"/>
-              <a:t>4/4/2025</a:t>
+              <a:t>4/30/2025</a:t>
             </a:fld>
             <a:endParaRPr lang="en-US"/>
           </a:p>
@@ -2069,7 +2069,7 @@
           <a:p>
             <a:fld id="{2D8659F3-DB80-4E75-82CE-949E02E89EB1}" type="datetimeFigureOut">
               <a:rPr lang="en-US" smtClean="0"/>
-              <a:t>4/4/2025</a:t>
+              <a:t>4/30/2025</a:t>
             </a:fld>
             <a:endParaRPr lang="en-US"/>
           </a:p>
@@ -2380,7 +2380,7 @@
           <a:p>
             <a:fld id="{2D8659F3-DB80-4E75-82CE-949E02E89EB1}" type="datetimeFigureOut">
               <a:rPr lang="en-US" smtClean="0"/>
-              <a:t>4/4/2025</a:t>
+              <a:t>4/30/2025</a:t>
             </a:fld>
             <a:endParaRPr lang="en-US"/>
           </a:p>
@@ -2668,7 +2668,7 @@
           <a:p>
             <a:fld id="{2D8659F3-DB80-4E75-82CE-949E02E89EB1}" type="datetimeFigureOut">
               <a:rPr lang="en-US" smtClean="0"/>
-              <a:t>4/4/2025</a:t>
+              <a:t>4/30/2025</a:t>
             </a:fld>
             <a:endParaRPr lang="en-US"/>
           </a:p>
@@ -2909,7 +2909,7 @@
           <a:p>
             <a:fld id="{2D8659F3-DB80-4E75-82CE-949E02E89EB1}" type="datetimeFigureOut">
               <a:rPr lang="en-US" smtClean="0"/>
-              <a:t>4/4/2025</a:t>
+              <a:t>4/30/2025</a:t>
             </a:fld>
             <a:endParaRPr lang="en-US"/>
           </a:p>
@@ -3328,10 +3328,10 @@
       </p:grpSpPr>
       <p:sp>
         <p:nvSpPr>
-          <p:cNvPr id="4" name="Oval 3">
-            <a:extLst>
-              <a:ext uri="{FF2B5EF4-FFF2-40B4-BE49-F238E27FC236}">
-                <a16:creationId xmlns:a16="http://schemas.microsoft.com/office/drawing/2014/main" id="{879A390D-1B3D-5524-CF71-4E824DE500BE}"/>
+          <p:cNvPr id="92" name="Rectangle 91">
+            <a:extLst>
+              <a:ext uri="{FF2B5EF4-FFF2-40B4-BE49-F238E27FC236}">
+                <a16:creationId xmlns:a16="http://schemas.microsoft.com/office/drawing/2014/main" id="{8810A183-08CF-A2CF-5938-92BCC7F2271C}"/>
               </a:ext>
             </a:extLst>
           </p:cNvPr>
@@ -3340,12 +3340,20 @@
         </p:nvSpPr>
         <p:spPr>
           <a:xfrm>
-            <a:off x="733025" y="2821910"/>
-            <a:ext cx="1466053" cy="1214176"/>
-          </a:xfrm>
-          <a:prstGeom prst="ellipse">
+            <a:off x="9027611" y="3251662"/>
+            <a:ext cx="2404524" cy="2216374"/>
+          </a:xfrm>
+          <a:prstGeom prst="rect">
             <a:avLst/>
           </a:prstGeom>
+          <a:solidFill>
+            <a:schemeClr val="bg1">
+              <a:lumMod val="95000"/>
+            </a:schemeClr>
+          </a:solidFill>
+          <a:ln>
+            <a:noFill/>
+          </a:ln>
         </p:spPr>
         <p:style>
           <a:lnRef idx="2">
@@ -3368,209 +3376,39 @@
           <a:lstStyle/>
           <a:p>
             <a:pPr algn="ctr"/>
-            <a:r>
-              <a:rPr lang="en-US" dirty="0"/>
-              <a:t>Initial</a:t>
-            </a:r>
-          </a:p>
-          <a:p>
-            <a:pPr algn="ctr"/>
-            <a:r>
-              <a:rPr lang="en-US" dirty="0"/>
-              <a:t>thinking stage</a:t>
-            </a:r>
-          </a:p>
-        </p:txBody>
-      </p:sp>
-      <p:cxnSp>
-        <p:nvCxnSpPr>
-          <p:cNvPr id="6" name="Straight Arrow Connector 5">
-            <a:extLst>
-              <a:ext uri="{FF2B5EF4-FFF2-40B4-BE49-F238E27FC236}">
-                <a16:creationId xmlns:a16="http://schemas.microsoft.com/office/drawing/2014/main" id="{475A42E6-5B41-9787-CD30-C8D94182221D}"/>
-              </a:ext>
-            </a:extLst>
-          </p:cNvPr>
-          <p:cNvCxnSpPr>
-            <a:cxnSpLocks/>
-            <a:endCxn id="4" idx="2"/>
-          </p:cNvCxnSpPr>
+            <a:endParaRPr lang="en-US"/>
+          </a:p>
+        </p:txBody>
+      </p:sp>
+      <p:sp>
+        <p:nvSpPr>
+          <p:cNvPr id="100" name="Arrow: Right 99">
+            <a:extLst>
+              <a:ext uri="{FF2B5EF4-FFF2-40B4-BE49-F238E27FC236}">
+                <a16:creationId xmlns:a16="http://schemas.microsoft.com/office/drawing/2014/main" id="{4EB05B44-AC19-D2BB-4591-201627E56FF1}"/>
+              </a:ext>
+            </a:extLst>
+          </p:cNvPr>
+          <p:cNvSpPr/>
           <p:nvPr/>
-        </p:nvCxnSpPr>
-        <p:spPr>
-          <a:xfrm>
-            <a:off x="0" y="3428998"/>
-            <a:ext cx="733025" cy="0"/>
-          </a:xfrm>
-          <a:prstGeom prst="straightConnector1">
+        </p:nvSpPr>
+        <p:spPr>
+          <a:xfrm>
+            <a:off x="8413176" y="4076270"/>
+            <a:ext cx="694418" cy="532596"/>
+          </a:xfrm>
+          <a:prstGeom prst="rightArrow">
             <a:avLst/>
           </a:prstGeom>
+          <a:solidFill>
+            <a:schemeClr val="accent2">
+              <a:lumMod val="20000"/>
+              <a:lumOff val="80000"/>
+            </a:schemeClr>
+          </a:solidFill>
           <a:ln>
-            <a:tailEnd type="triangle"/>
+            <a:noFill/>
           </a:ln>
-        </p:spPr>
-        <p:style>
-          <a:lnRef idx="2">
-            <a:schemeClr val="dk1"/>
-          </a:lnRef>
-          <a:fillRef idx="0">
-            <a:schemeClr val="dk1"/>
-          </a:fillRef>
-          <a:effectRef idx="1">
-            <a:schemeClr val="dk1"/>
-          </a:effectRef>
-          <a:fontRef idx="minor">
-            <a:schemeClr val="tx1"/>
-          </a:fontRef>
-        </p:style>
-      </p:cxnSp>
-      <p:sp>
-        <p:nvSpPr>
-          <p:cNvPr id="7" name="TextBox 6">
-            <a:extLst>
-              <a:ext uri="{FF2B5EF4-FFF2-40B4-BE49-F238E27FC236}">
-                <a16:creationId xmlns:a16="http://schemas.microsoft.com/office/drawing/2014/main" id="{D4E2CF3C-1CDD-9A12-068C-C488A44F25C4}"/>
-              </a:ext>
-            </a:extLst>
-          </p:cNvPr>
-          <p:cNvSpPr txBox="1"/>
-          <p:nvPr/>
-        </p:nvSpPr>
-        <p:spPr>
-          <a:xfrm>
-            <a:off x="6112" y="3059666"/>
-            <a:ext cx="704039" cy="369332"/>
-          </a:xfrm>
-          <a:prstGeom prst="rect">
-            <a:avLst/>
-          </a:prstGeom>
-          <a:noFill/>
-        </p:spPr>
-        <p:txBody>
-          <a:bodyPr wrap="none" rtlCol="0">
-            <a:spAutoFit/>
-          </a:bodyPr>
-          <a:lstStyle/>
-          <a:p>
-            <a:r>
-              <a:rPr lang="en-US" dirty="0"/>
-              <a:t>Input</a:t>
-            </a:r>
-          </a:p>
-        </p:txBody>
-      </p:sp>
-      <p:sp>
-        <p:nvSpPr>
-          <p:cNvPr id="13" name="Oval 12">
-            <a:extLst>
-              <a:ext uri="{FF2B5EF4-FFF2-40B4-BE49-F238E27FC236}">
-                <a16:creationId xmlns:a16="http://schemas.microsoft.com/office/drawing/2014/main" id="{62FEF92B-AB9E-8820-A915-5E7AD3836D12}"/>
-              </a:ext>
-            </a:extLst>
-          </p:cNvPr>
-          <p:cNvSpPr/>
-          <p:nvPr/>
-        </p:nvSpPr>
-        <p:spPr>
-          <a:xfrm>
-            <a:off x="2698985" y="2821910"/>
-            <a:ext cx="1466053" cy="1214176"/>
-          </a:xfrm>
-          <a:prstGeom prst="ellipse">
-            <a:avLst/>
-          </a:prstGeom>
-        </p:spPr>
-        <p:style>
-          <a:lnRef idx="2">
-            <a:schemeClr val="accent3">
-              <a:shade val="15000"/>
-            </a:schemeClr>
-          </a:lnRef>
-          <a:fillRef idx="1">
-            <a:schemeClr val="accent3"/>
-          </a:fillRef>
-          <a:effectRef idx="0">
-            <a:schemeClr val="accent3"/>
-          </a:effectRef>
-          <a:fontRef idx="minor">
-            <a:schemeClr val="lt1"/>
-          </a:fontRef>
-        </p:style>
-        <p:txBody>
-          <a:bodyPr rtlCol="0" anchor="ctr"/>
-          <a:lstStyle/>
-          <a:p>
-            <a:pPr algn="ctr"/>
-            <a:r>
-              <a:rPr lang="en-US" sz="1200" dirty="0"/>
-              <a:t>Standardize input to DTXSID</a:t>
-            </a:r>
-          </a:p>
-        </p:txBody>
-      </p:sp>
-      <p:cxnSp>
-        <p:nvCxnSpPr>
-          <p:cNvPr id="14" name="Straight Arrow Connector 13">
-            <a:extLst>
-              <a:ext uri="{FF2B5EF4-FFF2-40B4-BE49-F238E27FC236}">
-                <a16:creationId xmlns:a16="http://schemas.microsoft.com/office/drawing/2014/main" id="{BA3FED41-2A23-7A93-C2BF-E28ADDFE50B7}"/>
-              </a:ext>
-            </a:extLst>
-          </p:cNvPr>
-          <p:cNvCxnSpPr>
-            <a:cxnSpLocks/>
-            <a:stCxn id="4" idx="6"/>
-            <a:endCxn id="13" idx="2"/>
-          </p:cNvCxnSpPr>
-          <p:nvPr/>
-        </p:nvCxnSpPr>
-        <p:spPr>
-          <a:xfrm>
-            <a:off x="2199078" y="3428998"/>
-            <a:ext cx="499907" cy="0"/>
-          </a:xfrm>
-          <a:prstGeom prst="straightConnector1">
-            <a:avLst/>
-          </a:prstGeom>
-          <a:ln>
-            <a:tailEnd type="triangle"/>
-          </a:ln>
-        </p:spPr>
-        <p:style>
-          <a:lnRef idx="2">
-            <a:schemeClr val="dk1"/>
-          </a:lnRef>
-          <a:fillRef idx="0">
-            <a:schemeClr val="dk1"/>
-          </a:fillRef>
-          <a:effectRef idx="1">
-            <a:schemeClr val="dk1"/>
-          </a:effectRef>
-          <a:fontRef idx="minor">
-            <a:schemeClr val="tx1"/>
-          </a:fontRef>
-        </p:style>
-      </p:cxnSp>
-      <p:sp>
-        <p:nvSpPr>
-          <p:cNvPr id="18" name="Oval 17">
-            <a:extLst>
-              <a:ext uri="{FF2B5EF4-FFF2-40B4-BE49-F238E27FC236}">
-                <a16:creationId xmlns:a16="http://schemas.microsoft.com/office/drawing/2014/main" id="{081BC4CE-48F5-9BA8-0B8F-B3896D38F40C}"/>
-              </a:ext>
-            </a:extLst>
-          </p:cNvPr>
-          <p:cNvSpPr/>
-          <p:nvPr/>
-        </p:nvSpPr>
-        <p:spPr>
-          <a:xfrm>
-            <a:off x="5186207" y="5511772"/>
-            <a:ext cx="1466053" cy="1214176"/>
-          </a:xfrm>
-          <a:prstGeom prst="ellipse">
-            <a:avLst/>
-          </a:prstGeom>
         </p:spPr>
         <p:style>
           <a:lnRef idx="2">
@@ -3593,19 +3431,16 @@
           <a:lstStyle/>
           <a:p>
             <a:pPr algn="ctr"/>
-            <a:r>
-              <a:rPr lang="en-US" sz="1600" dirty="0"/>
-              <a:t>END</a:t>
-            </a:r>
-          </a:p>
-        </p:txBody>
-      </p:sp>
-      <p:sp>
-        <p:nvSpPr>
-          <p:cNvPr id="24" name="Oval 23">
-            <a:extLst>
-              <a:ext uri="{FF2B5EF4-FFF2-40B4-BE49-F238E27FC236}">
-                <a16:creationId xmlns:a16="http://schemas.microsoft.com/office/drawing/2014/main" id="{7F6F0C98-2F3B-0101-12C9-B3667677416D}"/>
+            <a:endParaRPr lang="en-US"/>
+          </a:p>
+        </p:txBody>
+      </p:sp>
+      <p:sp>
+        <p:nvSpPr>
+          <p:cNvPr id="99" name="Arrow: Right 98">
+            <a:extLst>
+              <a:ext uri="{FF2B5EF4-FFF2-40B4-BE49-F238E27FC236}">
+                <a16:creationId xmlns:a16="http://schemas.microsoft.com/office/drawing/2014/main" id="{383D9C5E-7E0A-987D-3814-17A844B4890A}"/>
               </a:ext>
             </a:extLst>
           </p:cNvPr>
@@ -3613,9 +3448,490 @@
           <p:nvPr/>
         </p:nvSpPr>
         <p:spPr>
-          <a:xfrm>
-            <a:off x="7592620" y="3466896"/>
-            <a:ext cx="1466053" cy="1214176"/>
+          <a:xfrm rot="19905919">
+            <a:off x="8573559" y="5087677"/>
+            <a:ext cx="694418" cy="532596"/>
+          </a:xfrm>
+          <a:prstGeom prst="rightArrow">
+            <a:avLst/>
+          </a:prstGeom>
+          <a:solidFill>
+            <a:schemeClr val="accent6">
+              <a:lumMod val="20000"/>
+              <a:lumOff val="80000"/>
+            </a:schemeClr>
+          </a:solidFill>
+          <a:ln>
+            <a:noFill/>
+          </a:ln>
+        </p:spPr>
+        <p:style>
+          <a:lnRef idx="2">
+            <a:schemeClr val="accent1">
+              <a:shade val="15000"/>
+            </a:schemeClr>
+          </a:lnRef>
+          <a:fillRef idx="1">
+            <a:schemeClr val="accent1"/>
+          </a:fillRef>
+          <a:effectRef idx="0">
+            <a:schemeClr val="accent1"/>
+          </a:effectRef>
+          <a:fontRef idx="minor">
+            <a:schemeClr val="lt1"/>
+          </a:fontRef>
+        </p:style>
+        <p:txBody>
+          <a:bodyPr rtlCol="0" anchor="ctr"/>
+          <a:lstStyle/>
+          <a:p>
+            <a:pPr algn="ctr"/>
+            <a:endParaRPr lang="en-US"/>
+          </a:p>
+        </p:txBody>
+      </p:sp>
+      <p:sp>
+        <p:nvSpPr>
+          <p:cNvPr id="97" name="Arrow: Right 96">
+            <a:extLst>
+              <a:ext uri="{FF2B5EF4-FFF2-40B4-BE49-F238E27FC236}">
+                <a16:creationId xmlns:a16="http://schemas.microsoft.com/office/drawing/2014/main" id="{11F2193F-AD78-F694-7B4C-858BBD742C10}"/>
+              </a:ext>
+            </a:extLst>
+          </p:cNvPr>
+          <p:cNvSpPr/>
+          <p:nvPr/>
+        </p:nvSpPr>
+        <p:spPr>
+          <a:xfrm rot="2093903">
+            <a:off x="8612482" y="3138313"/>
+            <a:ext cx="694418" cy="532596"/>
+          </a:xfrm>
+          <a:prstGeom prst="rightArrow">
+            <a:avLst/>
+          </a:prstGeom>
+          <a:solidFill>
+            <a:schemeClr val="accent5">
+              <a:lumMod val="20000"/>
+              <a:lumOff val="80000"/>
+            </a:schemeClr>
+          </a:solidFill>
+          <a:ln>
+            <a:noFill/>
+          </a:ln>
+        </p:spPr>
+        <p:style>
+          <a:lnRef idx="2">
+            <a:schemeClr val="accent1">
+              <a:shade val="15000"/>
+            </a:schemeClr>
+          </a:lnRef>
+          <a:fillRef idx="1">
+            <a:schemeClr val="accent1"/>
+          </a:fillRef>
+          <a:effectRef idx="0">
+            <a:schemeClr val="accent1"/>
+          </a:effectRef>
+          <a:fontRef idx="minor">
+            <a:schemeClr val="lt1"/>
+          </a:fontRef>
+        </p:style>
+        <p:txBody>
+          <a:bodyPr rtlCol="0" anchor="ctr"/>
+          <a:lstStyle/>
+          <a:p>
+            <a:pPr algn="ctr"/>
+            <a:endParaRPr lang="en-US"/>
+          </a:p>
+        </p:txBody>
+      </p:sp>
+      <p:sp>
+        <p:nvSpPr>
+          <p:cNvPr id="96" name="Rectangle 95">
+            <a:extLst>
+              <a:ext uri="{FF2B5EF4-FFF2-40B4-BE49-F238E27FC236}">
+                <a16:creationId xmlns:a16="http://schemas.microsoft.com/office/drawing/2014/main" id="{3CC6662B-D813-B0B1-31E2-E8D00A922B59}"/>
+              </a:ext>
+            </a:extLst>
+          </p:cNvPr>
+          <p:cNvSpPr/>
+          <p:nvPr/>
+        </p:nvSpPr>
+        <p:spPr>
+          <a:xfrm>
+            <a:off x="4577789" y="4923469"/>
+            <a:ext cx="4187681" cy="1110876"/>
+          </a:xfrm>
+          <a:prstGeom prst="rect">
+            <a:avLst/>
+          </a:prstGeom>
+          <a:solidFill>
+            <a:schemeClr val="accent3">
+              <a:lumMod val="20000"/>
+              <a:lumOff val="80000"/>
+            </a:schemeClr>
+          </a:solidFill>
+          <a:ln>
+            <a:noFill/>
+          </a:ln>
+        </p:spPr>
+        <p:style>
+          <a:lnRef idx="2">
+            <a:schemeClr val="accent1">
+              <a:shade val="15000"/>
+            </a:schemeClr>
+          </a:lnRef>
+          <a:fillRef idx="1">
+            <a:schemeClr val="accent1"/>
+          </a:fillRef>
+          <a:effectRef idx="0">
+            <a:schemeClr val="accent1"/>
+          </a:effectRef>
+          <a:fontRef idx="minor">
+            <a:schemeClr val="lt1"/>
+          </a:fontRef>
+        </p:style>
+        <p:txBody>
+          <a:bodyPr rtlCol="0" anchor="ctr"/>
+          <a:lstStyle/>
+          <a:p>
+            <a:pPr algn="ctr"/>
+            <a:endParaRPr lang="en-US"/>
+          </a:p>
+        </p:txBody>
+      </p:sp>
+      <p:sp>
+        <p:nvSpPr>
+          <p:cNvPr id="95" name="Rectangle 94">
+            <a:extLst>
+              <a:ext uri="{FF2B5EF4-FFF2-40B4-BE49-F238E27FC236}">
+                <a16:creationId xmlns:a16="http://schemas.microsoft.com/office/drawing/2014/main" id="{FACC67BA-361E-1EDB-E313-BE67FD809672}"/>
+              </a:ext>
+            </a:extLst>
+          </p:cNvPr>
+          <p:cNvSpPr/>
+          <p:nvPr/>
+        </p:nvSpPr>
+        <p:spPr>
+          <a:xfrm>
+            <a:off x="4584224" y="3804651"/>
+            <a:ext cx="4187681" cy="1042651"/>
+          </a:xfrm>
+          <a:prstGeom prst="rect">
+            <a:avLst/>
+          </a:prstGeom>
+          <a:solidFill>
+            <a:schemeClr val="accent2">
+              <a:lumMod val="20000"/>
+              <a:lumOff val="80000"/>
+            </a:schemeClr>
+          </a:solidFill>
+          <a:ln>
+            <a:noFill/>
+          </a:ln>
+        </p:spPr>
+        <p:style>
+          <a:lnRef idx="2">
+            <a:schemeClr val="accent1">
+              <a:shade val="15000"/>
+            </a:schemeClr>
+          </a:lnRef>
+          <a:fillRef idx="1">
+            <a:schemeClr val="accent1"/>
+          </a:fillRef>
+          <a:effectRef idx="0">
+            <a:schemeClr val="accent1"/>
+          </a:effectRef>
+          <a:fontRef idx="minor">
+            <a:schemeClr val="lt1"/>
+          </a:fontRef>
+        </p:style>
+        <p:txBody>
+          <a:bodyPr rtlCol="0" anchor="ctr"/>
+          <a:lstStyle/>
+          <a:p>
+            <a:pPr algn="ctr"/>
+            <a:endParaRPr lang="en-US"/>
+          </a:p>
+        </p:txBody>
+      </p:sp>
+      <p:sp>
+        <p:nvSpPr>
+          <p:cNvPr id="93" name="Rectangle 92">
+            <a:extLst>
+              <a:ext uri="{FF2B5EF4-FFF2-40B4-BE49-F238E27FC236}">
+                <a16:creationId xmlns:a16="http://schemas.microsoft.com/office/drawing/2014/main" id="{79933495-8A6B-6B60-5EAE-4D3209A73653}"/>
+              </a:ext>
+            </a:extLst>
+          </p:cNvPr>
+          <p:cNvSpPr/>
+          <p:nvPr/>
+        </p:nvSpPr>
+        <p:spPr>
+          <a:xfrm>
+            <a:off x="4584224" y="2306836"/>
+            <a:ext cx="4187681" cy="1444896"/>
+          </a:xfrm>
+          <a:prstGeom prst="rect">
+            <a:avLst/>
+          </a:prstGeom>
+          <a:solidFill>
+            <a:schemeClr val="accent5">
+              <a:lumMod val="20000"/>
+              <a:lumOff val="80000"/>
+            </a:schemeClr>
+          </a:solidFill>
+          <a:ln>
+            <a:noFill/>
+          </a:ln>
+        </p:spPr>
+        <p:style>
+          <a:lnRef idx="2">
+            <a:schemeClr val="accent1">
+              <a:shade val="15000"/>
+            </a:schemeClr>
+          </a:lnRef>
+          <a:fillRef idx="1">
+            <a:schemeClr val="accent1"/>
+          </a:fillRef>
+          <a:effectRef idx="0">
+            <a:schemeClr val="accent1"/>
+          </a:effectRef>
+          <a:fontRef idx="minor">
+            <a:schemeClr val="lt1"/>
+          </a:fontRef>
+        </p:style>
+        <p:txBody>
+          <a:bodyPr rtlCol="0" anchor="ctr"/>
+          <a:lstStyle/>
+          <a:p>
+            <a:pPr algn="ctr"/>
+            <a:endParaRPr lang="en-US"/>
+          </a:p>
+        </p:txBody>
+      </p:sp>
+      <p:sp>
+        <p:nvSpPr>
+          <p:cNvPr id="91" name="Rectangle 90">
+            <a:extLst>
+              <a:ext uri="{FF2B5EF4-FFF2-40B4-BE49-F238E27FC236}">
+                <a16:creationId xmlns:a16="http://schemas.microsoft.com/office/drawing/2014/main" id="{C0A5188E-C62B-7EB4-841F-F64B3F82C19F}"/>
+              </a:ext>
+            </a:extLst>
+          </p:cNvPr>
+          <p:cNvSpPr/>
+          <p:nvPr/>
+        </p:nvSpPr>
+        <p:spPr>
+          <a:xfrm>
+            <a:off x="1428750" y="3251662"/>
+            <a:ext cx="2993741" cy="2216374"/>
+          </a:xfrm>
+          <a:prstGeom prst="rect">
+            <a:avLst/>
+          </a:prstGeom>
+          <a:solidFill>
+            <a:schemeClr val="bg1">
+              <a:lumMod val="95000"/>
+            </a:schemeClr>
+          </a:solidFill>
+          <a:ln>
+            <a:noFill/>
+          </a:ln>
+        </p:spPr>
+        <p:style>
+          <a:lnRef idx="2">
+            <a:schemeClr val="accent1">
+              <a:shade val="15000"/>
+            </a:schemeClr>
+          </a:lnRef>
+          <a:fillRef idx="1">
+            <a:schemeClr val="accent1"/>
+          </a:fillRef>
+          <a:effectRef idx="0">
+            <a:schemeClr val="accent1"/>
+          </a:effectRef>
+          <a:fontRef idx="minor">
+            <a:schemeClr val="lt1"/>
+          </a:fontRef>
+        </p:style>
+        <p:txBody>
+          <a:bodyPr rtlCol="0" anchor="ctr"/>
+          <a:lstStyle/>
+          <a:p>
+            <a:pPr algn="ctr"/>
+            <a:endParaRPr lang="en-US"/>
+          </a:p>
+        </p:txBody>
+      </p:sp>
+      <p:sp>
+        <p:nvSpPr>
+          <p:cNvPr id="4" name="Oval 3">
+            <a:extLst>
+              <a:ext uri="{FF2B5EF4-FFF2-40B4-BE49-F238E27FC236}">
+                <a16:creationId xmlns:a16="http://schemas.microsoft.com/office/drawing/2014/main" id="{879A390D-1B3D-5524-CF71-4E824DE500BE}"/>
+              </a:ext>
+            </a:extLst>
+          </p:cNvPr>
+          <p:cNvSpPr/>
+          <p:nvPr/>
+        </p:nvSpPr>
+        <p:spPr>
+          <a:xfrm>
+            <a:off x="1593486" y="3823526"/>
+            <a:ext cx="1266994" cy="1033947"/>
+          </a:xfrm>
+          <a:prstGeom prst="ellipse">
+            <a:avLst/>
+          </a:prstGeom>
+        </p:spPr>
+        <p:style>
+          <a:lnRef idx="2">
+            <a:schemeClr val="accent1">
+              <a:shade val="15000"/>
+            </a:schemeClr>
+          </a:lnRef>
+          <a:fillRef idx="1">
+            <a:schemeClr val="accent1"/>
+          </a:fillRef>
+          <a:effectRef idx="0">
+            <a:schemeClr val="accent1"/>
+          </a:effectRef>
+          <a:fontRef idx="minor">
+            <a:schemeClr val="lt1"/>
+          </a:fontRef>
+        </p:style>
+        <p:txBody>
+          <a:bodyPr rtlCol="0" anchor="ctr"/>
+          <a:lstStyle/>
+          <a:p>
+            <a:pPr algn="ctr"/>
+            <a:r>
+              <a:rPr lang="en-US" dirty="0"/>
+              <a:t>Initial</a:t>
+            </a:r>
+          </a:p>
+          <a:p>
+            <a:pPr algn="ctr"/>
+            <a:r>
+              <a:rPr lang="en-US" dirty="0"/>
+              <a:t>stage</a:t>
+            </a:r>
+          </a:p>
+        </p:txBody>
+      </p:sp>
+      <p:cxnSp>
+        <p:nvCxnSpPr>
+          <p:cNvPr id="6" name="Straight Arrow Connector 5">
+            <a:extLst>
+              <a:ext uri="{FF2B5EF4-FFF2-40B4-BE49-F238E27FC236}">
+                <a16:creationId xmlns:a16="http://schemas.microsoft.com/office/drawing/2014/main" id="{475A42E6-5B41-9787-CD30-C8D94182221D}"/>
+              </a:ext>
+            </a:extLst>
+          </p:cNvPr>
+          <p:cNvCxnSpPr>
+            <a:cxnSpLocks/>
+            <a:endCxn id="4" idx="2"/>
+          </p:cNvCxnSpPr>
+          <p:nvPr/>
+        </p:nvCxnSpPr>
+        <p:spPr>
+          <a:xfrm>
+            <a:off x="1371332" y="4340500"/>
+            <a:ext cx="222154" cy="0"/>
+          </a:xfrm>
+          <a:prstGeom prst="straightConnector1">
+            <a:avLst/>
+          </a:prstGeom>
+          <a:ln>
+            <a:tailEnd type="triangle"/>
+          </a:ln>
+        </p:spPr>
+        <p:style>
+          <a:lnRef idx="2">
+            <a:schemeClr val="dk1"/>
+          </a:lnRef>
+          <a:fillRef idx="0">
+            <a:schemeClr val="dk1"/>
+          </a:fillRef>
+          <a:effectRef idx="1">
+            <a:schemeClr val="dk1"/>
+          </a:effectRef>
+          <a:fontRef idx="minor">
+            <a:schemeClr val="tx1"/>
+          </a:fontRef>
+        </p:style>
+      </p:cxnSp>
+      <p:sp>
+        <p:nvSpPr>
+          <p:cNvPr id="13" name="Oval 12">
+            <a:extLst>
+              <a:ext uri="{FF2B5EF4-FFF2-40B4-BE49-F238E27FC236}">
+                <a16:creationId xmlns:a16="http://schemas.microsoft.com/office/drawing/2014/main" id="{62FEF92B-AB9E-8820-A915-5E7AD3836D12}"/>
+              </a:ext>
+            </a:extLst>
+          </p:cNvPr>
+          <p:cNvSpPr/>
+          <p:nvPr/>
+        </p:nvSpPr>
+        <p:spPr>
+          <a:xfrm>
+            <a:off x="4650252" y="2690296"/>
+            <a:ext cx="1266994" cy="1033947"/>
+          </a:xfrm>
+          <a:prstGeom prst="ellipse">
+            <a:avLst/>
+          </a:prstGeom>
+          <a:solidFill>
+            <a:schemeClr val="accent5">
+              <a:lumMod val="50000"/>
+            </a:schemeClr>
+          </a:solidFill>
+        </p:spPr>
+        <p:style>
+          <a:lnRef idx="2">
+            <a:schemeClr val="accent5">
+              <a:shade val="15000"/>
+            </a:schemeClr>
+          </a:lnRef>
+          <a:fillRef idx="1">
+            <a:schemeClr val="accent5"/>
+          </a:fillRef>
+          <a:effectRef idx="0">
+            <a:schemeClr val="accent5"/>
+          </a:effectRef>
+          <a:fontRef idx="minor">
+            <a:schemeClr val="lt1"/>
+          </a:fontRef>
+        </p:style>
+        <p:txBody>
+          <a:bodyPr rtlCol="0" anchor="ctr"/>
+          <a:lstStyle/>
+          <a:p>
+            <a:pPr algn="ctr"/>
+            <a:r>
+              <a:rPr lang="en-US" sz="1050" dirty="0"/>
+              <a:t>Standardize input to DTXSID</a:t>
+            </a:r>
+          </a:p>
+        </p:txBody>
+      </p:sp>
+      <p:sp>
+        <p:nvSpPr>
+          <p:cNvPr id="24" name="Oval 23">
+            <a:extLst>
+              <a:ext uri="{FF2B5EF4-FFF2-40B4-BE49-F238E27FC236}">
+                <a16:creationId xmlns:a16="http://schemas.microsoft.com/office/drawing/2014/main" id="{7F6F0C98-2F3B-0101-12C9-B3667677416D}"/>
+              </a:ext>
+            </a:extLst>
+          </p:cNvPr>
+          <p:cNvSpPr/>
+          <p:nvPr/>
+        </p:nvSpPr>
+        <p:spPr>
+          <a:xfrm>
+            <a:off x="4665210" y="3808380"/>
+            <a:ext cx="1266994" cy="1033947"/>
           </a:xfrm>
           <a:prstGeom prst="ellipse">
             <a:avLst/>
@@ -3643,78 +3959,8 @@
           <a:p>
             <a:pPr algn="ctr"/>
             <a:r>
-              <a:rPr lang="en-US" sz="1600" dirty="0"/>
+              <a:rPr lang="en-US" sz="1400" dirty="0"/>
               <a:t>RAG search from NTP docs</a:t>
-            </a:r>
-          </a:p>
-        </p:txBody>
-      </p:sp>
-      <p:sp>
-        <p:nvSpPr>
-          <p:cNvPr id="26" name="TextBox 25">
-            <a:extLst>
-              <a:ext uri="{FF2B5EF4-FFF2-40B4-BE49-F238E27FC236}">
-                <a16:creationId xmlns:a16="http://schemas.microsoft.com/office/drawing/2014/main" id="{4E558C97-77BB-DFB9-263E-3233CF21958F}"/>
-              </a:ext>
-            </a:extLst>
-          </p:cNvPr>
-          <p:cNvSpPr txBox="1"/>
-          <p:nvPr/>
-        </p:nvSpPr>
-        <p:spPr>
-          <a:xfrm>
-            <a:off x="4477608" y="802776"/>
-            <a:ext cx="1301125" cy="369332"/>
-          </a:xfrm>
-          <a:prstGeom prst="rect">
-            <a:avLst/>
-          </a:prstGeom>
-          <a:noFill/>
-        </p:spPr>
-        <p:txBody>
-          <a:bodyPr wrap="none" rtlCol="0">
-            <a:spAutoFit/>
-          </a:bodyPr>
-          <a:lstStyle/>
-          <a:p>
-            <a:r>
-              <a:rPr lang="en-US" dirty="0"/>
-              <a:t>Tool chains</a:t>
-            </a:r>
-          </a:p>
-        </p:txBody>
-      </p:sp>
-      <p:sp>
-        <p:nvSpPr>
-          <p:cNvPr id="27" name="TextBox 26">
-            <a:extLst>
-              <a:ext uri="{FF2B5EF4-FFF2-40B4-BE49-F238E27FC236}">
-                <a16:creationId xmlns:a16="http://schemas.microsoft.com/office/drawing/2014/main" id="{0C4FE498-C54F-1C77-A8F2-3CE9FF6490D9}"/>
-              </a:ext>
-            </a:extLst>
-          </p:cNvPr>
-          <p:cNvSpPr txBox="1"/>
-          <p:nvPr/>
-        </p:nvSpPr>
-        <p:spPr>
-          <a:xfrm>
-            <a:off x="491990" y="802776"/>
-            <a:ext cx="2126031" cy="369332"/>
-          </a:xfrm>
-          <a:prstGeom prst="rect">
-            <a:avLst/>
-          </a:prstGeom>
-          <a:noFill/>
-        </p:spPr>
-        <p:txBody>
-          <a:bodyPr wrap="none" rtlCol="0">
-            <a:spAutoFit/>
-          </a:bodyPr>
-          <a:lstStyle/>
-          <a:p>
-            <a:r>
-              <a:rPr lang="en-US" dirty="0"/>
-              <a:t>Data preprocessing</a:t>
             </a:r>
           </a:p>
         </p:txBody>
@@ -3733,8 +3979,8 @@
         </p:nvSpPr>
         <p:spPr>
           <a:xfrm>
-            <a:off x="9119523" y="3466896"/>
-            <a:ext cx="1466053" cy="1214176"/>
+            <a:off x="4650252" y="4951062"/>
+            <a:ext cx="1266994" cy="1033947"/>
           </a:xfrm>
           <a:prstGeom prst="ellipse">
             <a:avLst/>
@@ -3762,43 +4008,8 @@
           <a:p>
             <a:pPr algn="ctr"/>
             <a:r>
-              <a:rPr lang="en-US" sz="1600" dirty="0"/>
+              <a:rPr lang="en-US" sz="1200" dirty="0"/>
               <a:t>Literature search from PubMed</a:t>
-            </a:r>
-          </a:p>
-        </p:txBody>
-      </p:sp>
-      <p:sp>
-        <p:nvSpPr>
-          <p:cNvPr id="30" name="TextBox 29">
-            <a:extLst>
-              <a:ext uri="{FF2B5EF4-FFF2-40B4-BE49-F238E27FC236}">
-                <a16:creationId xmlns:a16="http://schemas.microsoft.com/office/drawing/2014/main" id="{47AD4F46-A16D-7301-5D52-413D834A7E4E}"/>
-              </a:ext>
-            </a:extLst>
-          </p:cNvPr>
-          <p:cNvSpPr txBox="1"/>
-          <p:nvPr/>
-        </p:nvSpPr>
-        <p:spPr>
-          <a:xfrm>
-            <a:off x="8352201" y="802776"/>
-            <a:ext cx="2284793" cy="369332"/>
-          </a:xfrm>
-          <a:prstGeom prst="rect">
-            <a:avLst/>
-          </a:prstGeom>
-          <a:noFill/>
-        </p:spPr>
-        <p:txBody>
-          <a:bodyPr wrap="none" rtlCol="0">
-            <a:spAutoFit/>
-          </a:bodyPr>
-          <a:lstStyle/>
-          <a:p>
-            <a:r>
-              <a:rPr lang="en-US" dirty="0"/>
-              <a:t>Fill in gaps from tools</a:t>
             </a:r>
           </a:p>
         </p:txBody>
@@ -3817,8 +4028,8 @@
         </p:nvSpPr>
         <p:spPr>
           <a:xfrm>
-            <a:off x="10663519" y="2030156"/>
-            <a:ext cx="1466053" cy="1214176"/>
+            <a:off x="9135071" y="3835973"/>
+            <a:ext cx="1266994" cy="1033947"/>
           </a:xfrm>
           <a:prstGeom prst="ellipse">
             <a:avLst/>
@@ -3846,8 +4057,8 @@
           <a:p>
             <a:pPr algn="ctr"/>
             <a:r>
-              <a:rPr lang="en-US" sz="1600" dirty="0"/>
-              <a:t>Fill in from training data</a:t>
+              <a:rPr lang="en-US" sz="1100" dirty="0"/>
+              <a:t>Add training data + summarize context</a:t>
             </a:r>
           </a:p>
         </p:txBody>
@@ -3866,8 +4077,8 @@
         </p:nvSpPr>
         <p:spPr>
           <a:xfrm>
-            <a:off x="4395145" y="2821909"/>
-            <a:ext cx="1466053" cy="1214176"/>
+            <a:off x="6085901" y="2690296"/>
+            <a:ext cx="1266994" cy="1033947"/>
           </a:xfrm>
           <a:prstGeom prst="ellipse">
             <a:avLst/>
@@ -3875,15 +4086,15 @@
         </p:spPr>
         <p:style>
           <a:lnRef idx="2">
-            <a:schemeClr val="accent3">
+            <a:schemeClr val="accent5">
               <a:shade val="15000"/>
             </a:schemeClr>
           </a:lnRef>
           <a:fillRef idx="1">
-            <a:schemeClr val="accent3"/>
+            <a:schemeClr val="accent5"/>
           </a:fillRef>
           <a:effectRef idx="0">
-            <a:schemeClr val="accent3"/>
+            <a:schemeClr val="accent5"/>
           </a:effectRef>
           <a:fontRef idx="minor">
             <a:schemeClr val="lt1"/>
@@ -3895,14 +4106,14 @@
           <a:p>
             <a:pPr algn="ctr"/>
             <a:r>
-              <a:rPr lang="en-US" sz="1200" dirty="0"/>
+              <a:rPr lang="en-US" sz="1050" dirty="0"/>
               <a:t>Tool</a:t>
             </a:r>
           </a:p>
           <a:p>
             <a:pPr algn="ctr"/>
             <a:r>
-              <a:rPr lang="en-US" sz="1200" dirty="0"/>
+              <a:rPr lang="en-US" sz="1050" dirty="0"/>
               <a:t>deliberation stage</a:t>
             </a:r>
           </a:p>
@@ -3925,9 +4136,844 @@
           <p:nvPr/>
         </p:nvCxnSpPr>
         <p:spPr>
+          <a:xfrm>
+            <a:off x="5917246" y="3207270"/>
+            <a:ext cx="168655" cy="0"/>
+          </a:xfrm>
+          <a:prstGeom prst="straightConnector1">
+            <a:avLst/>
+          </a:prstGeom>
+          <a:ln>
+            <a:tailEnd type="triangle"/>
+          </a:ln>
+        </p:spPr>
+        <p:style>
+          <a:lnRef idx="2">
+            <a:schemeClr val="dk1"/>
+          </a:lnRef>
+          <a:fillRef idx="0">
+            <a:schemeClr val="dk1"/>
+          </a:fillRef>
+          <a:effectRef idx="1">
+            <a:schemeClr val="dk1"/>
+          </a:effectRef>
+          <a:fontRef idx="minor">
+            <a:schemeClr val="tx1"/>
+          </a:fontRef>
+        </p:style>
+      </p:cxnSp>
+      <p:sp>
+        <p:nvSpPr>
+          <p:cNvPr id="5" name="Rectangle: Rounded Corners 4">
+            <a:extLst>
+              <a:ext uri="{FF2B5EF4-FFF2-40B4-BE49-F238E27FC236}">
+                <a16:creationId xmlns:a16="http://schemas.microsoft.com/office/drawing/2014/main" id="{E4D110DB-9B30-3827-6094-B7ADA210A3AA}"/>
+              </a:ext>
+            </a:extLst>
+          </p:cNvPr>
+          <p:cNvSpPr/>
+          <p:nvPr/>
+        </p:nvSpPr>
+        <p:spPr>
+          <a:xfrm>
+            <a:off x="7641505" y="2698673"/>
+            <a:ext cx="782206" cy="210882"/>
+          </a:xfrm>
+          <a:prstGeom prst="roundRect">
+            <a:avLst/>
+          </a:prstGeom>
+          <a:solidFill>
+            <a:schemeClr val="accent5">
+              <a:lumMod val="60000"/>
+              <a:lumOff val="40000"/>
+            </a:schemeClr>
+          </a:solidFill>
+        </p:spPr>
+        <p:style>
+          <a:lnRef idx="2">
+            <a:schemeClr val="accent5">
+              <a:shade val="15000"/>
+            </a:schemeClr>
+          </a:lnRef>
+          <a:fillRef idx="1">
+            <a:schemeClr val="accent5"/>
+          </a:fillRef>
+          <a:effectRef idx="0">
+            <a:schemeClr val="accent5"/>
+          </a:effectRef>
+          <a:fontRef idx="minor">
+            <a:schemeClr val="lt1"/>
+          </a:fontRef>
+        </p:style>
+        <p:txBody>
+          <a:bodyPr rtlCol="0" anchor="ctr"/>
+          <a:lstStyle/>
+          <a:p>
+            <a:pPr algn="ctr"/>
+            <a:r>
+              <a:rPr lang="en-US" sz="1000" dirty="0"/>
+              <a:t>Tool call 1</a:t>
+            </a:r>
+          </a:p>
+        </p:txBody>
+      </p:sp>
+      <p:sp>
+        <p:nvSpPr>
+          <p:cNvPr id="8" name="Rectangle: Rounded Corners 7">
+            <a:extLst>
+              <a:ext uri="{FF2B5EF4-FFF2-40B4-BE49-F238E27FC236}">
+                <a16:creationId xmlns:a16="http://schemas.microsoft.com/office/drawing/2014/main" id="{EB029D12-ED00-98A0-D117-D74A0658E6BD}"/>
+              </a:ext>
+            </a:extLst>
+          </p:cNvPr>
+          <p:cNvSpPr/>
+          <p:nvPr/>
+        </p:nvSpPr>
+        <p:spPr>
+          <a:xfrm>
+            <a:off x="7641505" y="2969398"/>
+            <a:ext cx="782206" cy="210882"/>
+          </a:xfrm>
+          <a:prstGeom prst="roundRect">
+            <a:avLst/>
+          </a:prstGeom>
+        </p:spPr>
+        <p:style>
+          <a:lnRef idx="2">
+            <a:schemeClr val="accent5">
+              <a:shade val="15000"/>
+            </a:schemeClr>
+          </a:lnRef>
+          <a:fillRef idx="1">
+            <a:schemeClr val="accent5"/>
+          </a:fillRef>
+          <a:effectRef idx="0">
+            <a:schemeClr val="accent5"/>
+          </a:effectRef>
+          <a:fontRef idx="minor">
+            <a:schemeClr val="lt1"/>
+          </a:fontRef>
+        </p:style>
+        <p:txBody>
+          <a:bodyPr rtlCol="0" anchor="ctr"/>
+          <a:lstStyle/>
+          <a:p>
+            <a:pPr algn="ctr"/>
+            <a:r>
+              <a:rPr lang="en-US" sz="1000" dirty="0"/>
+              <a:t>Tool call 2</a:t>
+            </a:r>
+          </a:p>
+        </p:txBody>
+      </p:sp>
+      <p:sp>
+        <p:nvSpPr>
+          <p:cNvPr id="9" name="Rectangle: Rounded Corners 8">
+            <a:extLst>
+              <a:ext uri="{FF2B5EF4-FFF2-40B4-BE49-F238E27FC236}">
+                <a16:creationId xmlns:a16="http://schemas.microsoft.com/office/drawing/2014/main" id="{0D86D933-D9DB-2F75-4DB4-F9A0259CC04E}"/>
+              </a:ext>
+            </a:extLst>
+          </p:cNvPr>
+          <p:cNvSpPr/>
+          <p:nvPr/>
+        </p:nvSpPr>
+        <p:spPr>
+          <a:xfrm>
+            <a:off x="7633878" y="3251662"/>
+            <a:ext cx="782206" cy="210882"/>
+          </a:xfrm>
+          <a:prstGeom prst="roundRect">
+            <a:avLst/>
+          </a:prstGeom>
+          <a:solidFill>
+            <a:schemeClr val="accent5">
+              <a:lumMod val="75000"/>
+            </a:schemeClr>
+          </a:solidFill>
+        </p:spPr>
+        <p:style>
+          <a:lnRef idx="2">
+            <a:schemeClr val="accent5">
+              <a:shade val="15000"/>
+            </a:schemeClr>
+          </a:lnRef>
+          <a:fillRef idx="1">
+            <a:schemeClr val="accent5"/>
+          </a:fillRef>
+          <a:effectRef idx="0">
+            <a:schemeClr val="accent5"/>
+          </a:effectRef>
+          <a:fontRef idx="minor">
+            <a:schemeClr val="lt1"/>
+          </a:fontRef>
+        </p:style>
+        <p:txBody>
+          <a:bodyPr rtlCol="0" anchor="ctr"/>
+          <a:lstStyle/>
+          <a:p>
+            <a:pPr algn="ctr"/>
+            <a:r>
+              <a:rPr lang="en-US" sz="1200" dirty="0"/>
+              <a:t>…</a:t>
+            </a:r>
+          </a:p>
+        </p:txBody>
+      </p:sp>
+      <p:sp>
+        <p:nvSpPr>
+          <p:cNvPr id="10" name="Rectangle: Rounded Corners 9">
+            <a:extLst>
+              <a:ext uri="{FF2B5EF4-FFF2-40B4-BE49-F238E27FC236}">
+                <a16:creationId xmlns:a16="http://schemas.microsoft.com/office/drawing/2014/main" id="{8D4EB21C-6DFA-A8F1-C39A-3C2940D1BBF2}"/>
+              </a:ext>
+            </a:extLst>
+          </p:cNvPr>
+          <p:cNvSpPr/>
+          <p:nvPr/>
+        </p:nvSpPr>
+        <p:spPr>
+          <a:xfrm>
+            <a:off x="7633878" y="3509431"/>
+            <a:ext cx="782206" cy="210882"/>
+          </a:xfrm>
+          <a:prstGeom prst="roundRect">
+            <a:avLst/>
+          </a:prstGeom>
+          <a:solidFill>
+            <a:schemeClr val="accent5">
+              <a:lumMod val="50000"/>
+            </a:schemeClr>
+          </a:solidFill>
+        </p:spPr>
+        <p:style>
+          <a:lnRef idx="2">
+            <a:schemeClr val="accent5">
+              <a:shade val="15000"/>
+            </a:schemeClr>
+          </a:lnRef>
+          <a:fillRef idx="1">
+            <a:schemeClr val="accent5"/>
+          </a:fillRef>
+          <a:effectRef idx="0">
+            <a:schemeClr val="accent5"/>
+          </a:effectRef>
+          <a:fontRef idx="minor">
+            <a:schemeClr val="lt1"/>
+          </a:fontRef>
+        </p:style>
+        <p:txBody>
+          <a:bodyPr rtlCol="0" anchor="ctr"/>
+          <a:lstStyle/>
+          <a:p>
+            <a:pPr algn="ctr"/>
+            <a:r>
+              <a:rPr lang="en-US" sz="1000" dirty="0"/>
+              <a:t>Tool call </a:t>
+            </a:r>
+            <a:r>
+              <a:rPr lang="en-US" sz="1000" i="1" dirty="0"/>
+              <a:t>N</a:t>
+            </a:r>
+          </a:p>
+        </p:txBody>
+      </p:sp>
+      <p:sp>
+        <p:nvSpPr>
+          <p:cNvPr id="34" name="Right Brace 33">
+            <a:extLst>
+              <a:ext uri="{FF2B5EF4-FFF2-40B4-BE49-F238E27FC236}">
+                <a16:creationId xmlns:a16="http://schemas.microsoft.com/office/drawing/2014/main" id="{EF59F8EB-0C00-A291-4B37-D692C09035DF}"/>
+              </a:ext>
+            </a:extLst>
+          </p:cNvPr>
+          <p:cNvSpPr/>
+          <p:nvPr/>
+        </p:nvSpPr>
+        <p:spPr>
+          <a:xfrm>
+            <a:off x="8450031" y="2706844"/>
+            <a:ext cx="253954" cy="1032344"/>
+          </a:xfrm>
+          <a:prstGeom prst="rightBrace">
+            <a:avLst/>
+          </a:prstGeom>
+          <a:ln>
+            <a:solidFill>
+              <a:schemeClr val="tx1"/>
+            </a:solidFill>
+          </a:ln>
+        </p:spPr>
+        <p:style>
+          <a:lnRef idx="2">
+            <a:schemeClr val="accent1"/>
+          </a:lnRef>
+          <a:fillRef idx="0">
+            <a:schemeClr val="accent1"/>
+          </a:fillRef>
+          <a:effectRef idx="1">
+            <a:schemeClr val="accent1"/>
+          </a:effectRef>
+          <a:fontRef idx="minor">
+            <a:schemeClr val="tx1"/>
+          </a:fontRef>
+        </p:style>
+        <p:txBody>
+          <a:bodyPr rtlCol="0" anchor="ctr"/>
+          <a:lstStyle/>
+          <a:p>
+            <a:pPr algn="ctr"/>
+            <a:endParaRPr lang="en-US"/>
+          </a:p>
+        </p:txBody>
+      </p:sp>
+      <p:sp>
+        <p:nvSpPr>
+          <p:cNvPr id="38" name="Left Brace 37">
+            <a:extLst>
+              <a:ext uri="{FF2B5EF4-FFF2-40B4-BE49-F238E27FC236}">
+                <a16:creationId xmlns:a16="http://schemas.microsoft.com/office/drawing/2014/main" id="{2EDC7610-95D6-24DC-ACD0-83AC6EC7A69F}"/>
+              </a:ext>
+            </a:extLst>
+          </p:cNvPr>
+          <p:cNvSpPr/>
+          <p:nvPr/>
+        </p:nvSpPr>
+        <p:spPr>
+          <a:xfrm>
+            <a:off x="7406896" y="2687593"/>
+            <a:ext cx="200662" cy="1032575"/>
+          </a:xfrm>
+          <a:prstGeom prst="leftBrace">
+            <a:avLst/>
+          </a:prstGeom>
+          <a:ln>
+            <a:solidFill>
+              <a:schemeClr val="tx1"/>
+            </a:solidFill>
+          </a:ln>
+        </p:spPr>
+        <p:style>
+          <a:lnRef idx="2">
+            <a:schemeClr val="accent1"/>
+          </a:lnRef>
+          <a:fillRef idx="0">
+            <a:schemeClr val="accent1"/>
+          </a:fillRef>
+          <a:effectRef idx="1">
+            <a:schemeClr val="accent1"/>
+          </a:effectRef>
+          <a:fontRef idx="minor">
+            <a:schemeClr val="tx1"/>
+          </a:fontRef>
+        </p:style>
+        <p:txBody>
+          <a:bodyPr rtlCol="0" anchor="ctr"/>
+          <a:lstStyle/>
+          <a:p>
+            <a:pPr algn="ctr"/>
+            <a:endParaRPr lang="en-US"/>
+          </a:p>
+        </p:txBody>
+      </p:sp>
+      <p:sp>
+        <p:nvSpPr>
+          <p:cNvPr id="23" name="TextBox 22">
+            <a:extLst>
+              <a:ext uri="{FF2B5EF4-FFF2-40B4-BE49-F238E27FC236}">
+                <a16:creationId xmlns:a16="http://schemas.microsoft.com/office/drawing/2014/main" id="{D750E409-A083-366C-3154-FC9FB413868D}"/>
+              </a:ext>
+            </a:extLst>
+          </p:cNvPr>
+          <p:cNvSpPr txBox="1"/>
+          <p:nvPr/>
+        </p:nvSpPr>
+        <p:spPr>
+          <a:xfrm>
+            <a:off x="620600" y="4155833"/>
+            <a:ext cx="883523" cy="369332"/>
+          </a:xfrm>
+          <a:prstGeom prst="rect">
+            <a:avLst/>
+          </a:prstGeom>
+          <a:noFill/>
+        </p:spPr>
+        <p:txBody>
+          <a:bodyPr wrap="square" rtlCol="0">
+            <a:spAutoFit/>
+          </a:bodyPr>
+          <a:lstStyle/>
+          <a:p>
+            <a:r>
+              <a:rPr lang="en-US" b="1" dirty="0"/>
+              <a:t>START</a:t>
+            </a:r>
+          </a:p>
+        </p:txBody>
+      </p:sp>
+      <p:sp>
+        <p:nvSpPr>
+          <p:cNvPr id="32" name="Oval 31">
+            <a:extLst>
+              <a:ext uri="{FF2B5EF4-FFF2-40B4-BE49-F238E27FC236}">
+                <a16:creationId xmlns:a16="http://schemas.microsoft.com/office/drawing/2014/main" id="{AF0E4DEB-0A24-4349-DBAB-684FDEF9AF2E}"/>
+              </a:ext>
+            </a:extLst>
+          </p:cNvPr>
+          <p:cNvSpPr/>
+          <p:nvPr/>
+        </p:nvSpPr>
+        <p:spPr>
+          <a:xfrm>
+            <a:off x="3058854" y="3827663"/>
+            <a:ext cx="1266994" cy="1033947"/>
+          </a:xfrm>
+          <a:prstGeom prst="ellipse">
+            <a:avLst/>
+          </a:prstGeom>
+        </p:spPr>
+        <p:style>
+          <a:lnRef idx="2">
+            <a:schemeClr val="accent1">
+              <a:shade val="15000"/>
+            </a:schemeClr>
+          </a:lnRef>
+          <a:fillRef idx="1">
+            <a:schemeClr val="accent1"/>
+          </a:fillRef>
+          <a:effectRef idx="0">
+            <a:schemeClr val="accent1"/>
+          </a:effectRef>
+          <a:fontRef idx="minor">
+            <a:schemeClr val="lt1"/>
+          </a:fontRef>
+        </p:style>
+        <p:txBody>
+          <a:bodyPr rtlCol="0" anchor="ctr"/>
+          <a:lstStyle/>
+          <a:p>
+            <a:pPr algn="ctr"/>
+            <a:r>
+              <a:rPr lang="en-US" sz="1200" dirty="0"/>
+              <a:t>Figure out if answer is in memory</a:t>
+            </a:r>
+          </a:p>
+        </p:txBody>
+      </p:sp>
+      <p:cxnSp>
+        <p:nvCxnSpPr>
+          <p:cNvPr id="33" name="Straight Arrow Connector 32">
+            <a:extLst>
+              <a:ext uri="{FF2B5EF4-FFF2-40B4-BE49-F238E27FC236}">
+                <a16:creationId xmlns:a16="http://schemas.microsoft.com/office/drawing/2014/main" id="{7A02405A-349B-B07C-390B-8C7507CEB90D}"/>
+              </a:ext>
+            </a:extLst>
+          </p:cNvPr>
+          <p:cNvCxnSpPr>
+            <a:cxnSpLocks/>
+            <a:stCxn id="4" idx="6"/>
+            <a:endCxn id="32" idx="2"/>
+          </p:cNvCxnSpPr>
+          <p:nvPr/>
+        </p:nvCxnSpPr>
+        <p:spPr>
+          <a:xfrm>
+            <a:off x="2860480" y="4340500"/>
+            <a:ext cx="198374" cy="4137"/>
+          </a:xfrm>
+          <a:prstGeom prst="straightConnector1">
+            <a:avLst/>
+          </a:prstGeom>
+          <a:ln>
+            <a:tailEnd type="triangle"/>
+          </a:ln>
+        </p:spPr>
+        <p:style>
+          <a:lnRef idx="2">
+            <a:schemeClr val="dk1"/>
+          </a:lnRef>
+          <a:fillRef idx="0">
+            <a:schemeClr val="dk1"/>
+          </a:fillRef>
+          <a:effectRef idx="1">
+            <a:schemeClr val="dk1"/>
+          </a:effectRef>
+          <a:fontRef idx="minor">
+            <a:schemeClr val="tx1"/>
+          </a:fontRef>
+        </p:style>
+      </p:cxnSp>
+      <p:sp>
+        <p:nvSpPr>
+          <p:cNvPr id="37" name="Left Brace 36">
+            <a:extLst>
+              <a:ext uri="{FF2B5EF4-FFF2-40B4-BE49-F238E27FC236}">
+                <a16:creationId xmlns:a16="http://schemas.microsoft.com/office/drawing/2014/main" id="{BE365F12-A5CA-9763-0559-8917C3D2E0DC}"/>
+              </a:ext>
+            </a:extLst>
+          </p:cNvPr>
+          <p:cNvSpPr/>
+          <p:nvPr/>
+        </p:nvSpPr>
+        <p:spPr>
+          <a:xfrm>
+            <a:off x="4373415" y="3182672"/>
+            <a:ext cx="200662" cy="2285364"/>
+          </a:xfrm>
+          <a:prstGeom prst="leftBrace">
+            <a:avLst/>
+          </a:prstGeom>
+          <a:ln>
+            <a:solidFill>
+              <a:schemeClr val="tx1"/>
+            </a:solidFill>
+          </a:ln>
+        </p:spPr>
+        <p:style>
+          <a:lnRef idx="2">
+            <a:schemeClr val="accent1"/>
+          </a:lnRef>
+          <a:fillRef idx="0">
+            <a:schemeClr val="accent1"/>
+          </a:fillRef>
+          <a:effectRef idx="1">
+            <a:schemeClr val="accent1"/>
+          </a:effectRef>
+          <a:fontRef idx="minor">
+            <a:schemeClr val="tx1"/>
+          </a:fontRef>
+        </p:style>
+        <p:txBody>
+          <a:bodyPr rtlCol="0" anchor="ctr"/>
+          <a:lstStyle/>
+          <a:p>
+            <a:pPr algn="ctr"/>
+            <a:endParaRPr lang="en-US"/>
+          </a:p>
+        </p:txBody>
+      </p:sp>
+      <p:sp>
+        <p:nvSpPr>
+          <p:cNvPr id="40" name="Right Brace 39">
+            <a:extLst>
+              <a:ext uri="{FF2B5EF4-FFF2-40B4-BE49-F238E27FC236}">
+                <a16:creationId xmlns:a16="http://schemas.microsoft.com/office/drawing/2014/main" id="{E44270FD-DD59-062B-A155-D3E1DAD894A6}"/>
+              </a:ext>
+            </a:extLst>
+          </p:cNvPr>
+          <p:cNvSpPr/>
+          <p:nvPr/>
+        </p:nvSpPr>
+        <p:spPr>
+          <a:xfrm>
+            <a:off x="8771905" y="3234926"/>
+            <a:ext cx="348208" cy="2236042"/>
+          </a:xfrm>
+          <a:prstGeom prst="rightBrace">
+            <a:avLst/>
+          </a:prstGeom>
+          <a:ln>
+            <a:solidFill>
+              <a:schemeClr val="tx1"/>
+            </a:solidFill>
+          </a:ln>
+        </p:spPr>
+        <p:style>
+          <a:lnRef idx="2">
+            <a:schemeClr val="accent1"/>
+          </a:lnRef>
+          <a:fillRef idx="0">
+            <a:schemeClr val="accent1"/>
+          </a:fillRef>
+          <a:effectRef idx="1">
+            <a:schemeClr val="accent1"/>
+          </a:effectRef>
+          <a:fontRef idx="minor">
+            <a:schemeClr val="tx1"/>
+          </a:fontRef>
+        </p:style>
+        <p:txBody>
+          <a:bodyPr rtlCol="0" anchor="ctr"/>
+          <a:lstStyle/>
+          <a:p>
+            <a:pPr algn="ctr"/>
+            <a:endParaRPr lang="en-US"/>
+          </a:p>
+        </p:txBody>
+      </p:sp>
+      <p:cxnSp>
+        <p:nvCxnSpPr>
+          <p:cNvPr id="55" name="Straight Arrow Connector 54">
+            <a:extLst>
+              <a:ext uri="{FF2B5EF4-FFF2-40B4-BE49-F238E27FC236}">
+                <a16:creationId xmlns:a16="http://schemas.microsoft.com/office/drawing/2014/main" id="{8283D82E-621D-7A31-0D77-D12F19B3BAF2}"/>
+              </a:ext>
+            </a:extLst>
+          </p:cNvPr>
+          <p:cNvCxnSpPr>
+            <a:cxnSpLocks/>
+          </p:cNvCxnSpPr>
+          <p:nvPr/>
+        </p:nvCxnSpPr>
+        <p:spPr>
+          <a:xfrm>
+            <a:off x="10416767" y="4352946"/>
+            <a:ext cx="198374" cy="4137"/>
+          </a:xfrm>
+          <a:prstGeom prst="straightConnector1">
+            <a:avLst/>
+          </a:prstGeom>
+          <a:ln>
+            <a:tailEnd type="triangle"/>
+          </a:ln>
+        </p:spPr>
+        <p:style>
+          <a:lnRef idx="2">
+            <a:schemeClr val="dk1"/>
+          </a:lnRef>
+          <a:fillRef idx="0">
+            <a:schemeClr val="dk1"/>
+          </a:fillRef>
+          <a:effectRef idx="1">
+            <a:schemeClr val="dk1"/>
+          </a:effectRef>
+          <a:fontRef idx="minor">
+            <a:schemeClr val="tx1"/>
+          </a:fontRef>
+        </p:style>
+      </p:cxnSp>
+      <p:sp>
+        <p:nvSpPr>
+          <p:cNvPr id="56" name="TextBox 55">
+            <a:extLst>
+              <a:ext uri="{FF2B5EF4-FFF2-40B4-BE49-F238E27FC236}">
+                <a16:creationId xmlns:a16="http://schemas.microsoft.com/office/drawing/2014/main" id="{7D64DE95-5A88-A41D-EBBD-6E3DC63E93CD}"/>
+              </a:ext>
+            </a:extLst>
+          </p:cNvPr>
+          <p:cNvSpPr txBox="1"/>
+          <p:nvPr/>
+        </p:nvSpPr>
+        <p:spPr>
+          <a:xfrm>
+            <a:off x="10560506" y="4168280"/>
+            <a:ext cx="883523" cy="369332"/>
+          </a:xfrm>
+          <a:prstGeom prst="rect">
+            <a:avLst/>
+          </a:prstGeom>
+          <a:noFill/>
+        </p:spPr>
+        <p:txBody>
+          <a:bodyPr wrap="square" rtlCol="0">
+            <a:spAutoFit/>
+          </a:bodyPr>
+          <a:lstStyle/>
+          <a:p>
+            <a:r>
+              <a:rPr lang="en-US" b="1" dirty="0"/>
+              <a:t>END</a:t>
+            </a:r>
+          </a:p>
+        </p:txBody>
+      </p:sp>
+      <p:cxnSp>
+        <p:nvCxnSpPr>
+          <p:cNvPr id="60" name="Connector: Elbow 59">
+            <a:extLst>
+              <a:ext uri="{FF2B5EF4-FFF2-40B4-BE49-F238E27FC236}">
+                <a16:creationId xmlns:a16="http://schemas.microsoft.com/office/drawing/2014/main" id="{232317E0-B206-4500-5C8B-F98F5D0672F4}"/>
+              </a:ext>
+            </a:extLst>
+          </p:cNvPr>
+          <p:cNvCxnSpPr>
+            <a:stCxn id="32" idx="4"/>
+            <a:endCxn id="31" idx="4"/>
+          </p:cNvCxnSpPr>
+          <p:nvPr/>
+        </p:nvCxnSpPr>
+        <p:spPr>
+          <a:xfrm rot="16200000" flipH="1">
+            <a:off x="6726304" y="1827656"/>
+            <a:ext cx="8310" cy="6076217"/>
+          </a:xfrm>
+          <a:prstGeom prst="bentConnector3">
+            <a:avLst>
+              <a:gd name="adj1" fmla="val 17293165"/>
+            </a:avLst>
+          </a:prstGeom>
+          <a:ln>
+            <a:solidFill>
+              <a:schemeClr val="tx1"/>
+            </a:solidFill>
+            <a:tailEnd type="triangle"/>
+          </a:ln>
+        </p:spPr>
+        <p:style>
+          <a:lnRef idx="2">
+            <a:schemeClr val="accent1"/>
+          </a:lnRef>
+          <a:fillRef idx="0">
+            <a:schemeClr val="accent1"/>
+          </a:fillRef>
+          <a:effectRef idx="1">
+            <a:schemeClr val="accent1"/>
+          </a:effectRef>
+          <a:fontRef idx="minor">
+            <a:schemeClr val="tx1"/>
+          </a:fontRef>
+        </p:style>
+      </p:cxnSp>
+      <p:sp>
+        <p:nvSpPr>
+          <p:cNvPr id="62" name="TextBox 61">
+            <a:extLst>
+              <a:ext uri="{FF2B5EF4-FFF2-40B4-BE49-F238E27FC236}">
+                <a16:creationId xmlns:a16="http://schemas.microsoft.com/office/drawing/2014/main" id="{096987F0-A4BD-6F41-3B27-87DD60881093}"/>
+              </a:ext>
+            </a:extLst>
+          </p:cNvPr>
+          <p:cNvSpPr txBox="1"/>
+          <p:nvPr/>
+        </p:nvSpPr>
+        <p:spPr>
+          <a:xfrm>
+            <a:off x="3639435" y="6269092"/>
+            <a:ext cx="6182048" cy="369332"/>
+          </a:xfrm>
+          <a:prstGeom prst="rect">
+            <a:avLst/>
+          </a:prstGeom>
+          <a:noFill/>
+        </p:spPr>
+        <p:txBody>
+          <a:bodyPr wrap="square" rtlCol="0">
+            <a:spAutoFit/>
+          </a:bodyPr>
+          <a:lstStyle/>
+          <a:p>
+            <a:pPr algn="ctr"/>
+            <a:r>
+              <a:rPr lang="en-US" sz="1800" dirty="0">
+                <a:solidFill>
+                  <a:schemeClr val="bg1">
+                    <a:lumMod val="50000"/>
+                  </a:schemeClr>
+                </a:solidFill>
+              </a:rPr>
+              <a:t>If answer to the query exists in the agent’s memory (context)</a:t>
+            </a:r>
+          </a:p>
+        </p:txBody>
+      </p:sp>
+      <p:sp>
+        <p:nvSpPr>
+          <p:cNvPr id="63" name="TextBox 62">
+            <a:extLst>
+              <a:ext uri="{FF2B5EF4-FFF2-40B4-BE49-F238E27FC236}">
+                <a16:creationId xmlns:a16="http://schemas.microsoft.com/office/drawing/2014/main" id="{2340FB42-602A-C0B5-EE01-EE326E36EF3D}"/>
+              </a:ext>
+            </a:extLst>
+          </p:cNvPr>
+          <p:cNvSpPr txBox="1"/>
+          <p:nvPr/>
+        </p:nvSpPr>
+        <p:spPr>
+          <a:xfrm>
+            <a:off x="3406618" y="2518319"/>
+            <a:ext cx="1372601" cy="830997"/>
+          </a:xfrm>
+          <a:prstGeom prst="rect">
+            <a:avLst/>
+          </a:prstGeom>
+          <a:noFill/>
+        </p:spPr>
+        <p:txBody>
+          <a:bodyPr wrap="square" rtlCol="0">
+            <a:spAutoFit/>
+          </a:bodyPr>
+          <a:lstStyle/>
+          <a:p>
+            <a:pPr algn="ctr"/>
+            <a:r>
+              <a:rPr lang="en-US" sz="1200" dirty="0">
+                <a:solidFill>
+                  <a:schemeClr val="bg1">
+                    <a:lumMod val="50000"/>
+                  </a:schemeClr>
+                </a:solidFill>
+              </a:rPr>
+              <a:t>If answer to the query is not in the agent’s memory (context)</a:t>
+            </a:r>
+          </a:p>
+        </p:txBody>
+      </p:sp>
+      <p:cxnSp>
+        <p:nvCxnSpPr>
+          <p:cNvPr id="67" name="Straight Connector 66">
+            <a:extLst>
+              <a:ext uri="{FF2B5EF4-FFF2-40B4-BE49-F238E27FC236}">
+                <a16:creationId xmlns:a16="http://schemas.microsoft.com/office/drawing/2014/main" id="{A5271328-338F-0AC2-4021-CA66B4F3344B}"/>
+              </a:ext>
+            </a:extLst>
+          </p:cNvPr>
+          <p:cNvCxnSpPr>
+            <a:cxnSpLocks/>
+            <a:stCxn id="63" idx="2"/>
+            <a:endCxn id="37" idx="1"/>
+          </p:cNvCxnSpPr>
+          <p:nvPr/>
+        </p:nvCxnSpPr>
+        <p:spPr>
+          <a:xfrm>
+            <a:off x="4092919" y="3349316"/>
+            <a:ext cx="280496" cy="976038"/>
+          </a:xfrm>
+          <a:prstGeom prst="line">
+            <a:avLst/>
+          </a:prstGeom>
+          <a:ln>
+            <a:solidFill>
+              <a:schemeClr val="bg1">
+                <a:lumMod val="50000"/>
+              </a:schemeClr>
+            </a:solidFill>
+          </a:ln>
+        </p:spPr>
+        <p:style>
+          <a:lnRef idx="2">
+            <a:schemeClr val="accent1"/>
+          </a:lnRef>
+          <a:fillRef idx="0">
+            <a:schemeClr val="accent1"/>
+          </a:fillRef>
+          <a:effectRef idx="1">
+            <a:schemeClr val="accent1"/>
+          </a:effectRef>
+          <a:fontRef idx="minor">
+            <a:schemeClr val="tx1"/>
+          </a:fontRef>
+        </p:style>
+      </p:cxnSp>
+      <p:cxnSp>
+        <p:nvCxnSpPr>
+          <p:cNvPr id="71" name="Straight Arrow Connector 70">
+            <a:extLst>
+              <a:ext uri="{FF2B5EF4-FFF2-40B4-BE49-F238E27FC236}">
+                <a16:creationId xmlns:a16="http://schemas.microsoft.com/office/drawing/2014/main" id="{A8C0F256-ABEE-75DF-ED65-03935AAB0D26}"/>
+              </a:ext>
+            </a:extLst>
+          </p:cNvPr>
+          <p:cNvCxnSpPr>
+            <a:cxnSpLocks/>
+            <a:stCxn id="24" idx="6"/>
+          </p:cNvCxnSpPr>
+          <p:nvPr/>
+        </p:nvCxnSpPr>
+        <p:spPr>
           <a:xfrm flipV="1">
-            <a:off x="4165038" y="3428997"/>
-            <a:ext cx="230107" cy="1"/>
+            <a:off x="5932204" y="4321216"/>
+            <a:ext cx="2824446" cy="4138"/>
           </a:xfrm>
           <a:prstGeom prst="straightConnector1">
             <a:avLst/>
@@ -3953,29 +4999,26 @@
       </p:cxnSp>
       <p:cxnSp>
         <p:nvCxnSpPr>
-          <p:cNvPr id="70" name="Connector: Elbow 69">
-            <a:extLst>
-              <a:ext uri="{FF2B5EF4-FFF2-40B4-BE49-F238E27FC236}">
-                <a16:creationId xmlns:a16="http://schemas.microsoft.com/office/drawing/2014/main" id="{7493B95D-42E5-91B9-AF61-3F01028D5685}"/>
+          <p:cNvPr id="75" name="Straight Arrow Connector 74">
+            <a:extLst>
+              <a:ext uri="{FF2B5EF4-FFF2-40B4-BE49-F238E27FC236}">
+                <a16:creationId xmlns:a16="http://schemas.microsoft.com/office/drawing/2014/main" id="{19127672-DD39-6F17-4752-D3C35D214616}"/>
               </a:ext>
             </a:extLst>
           </p:cNvPr>
           <p:cNvCxnSpPr>
             <a:cxnSpLocks/>
-            <a:stCxn id="44" idx="4"/>
-            <a:endCxn id="18" idx="0"/>
+            <a:stCxn id="28" idx="6"/>
           </p:cNvCxnSpPr>
           <p:nvPr/>
         </p:nvCxnSpPr>
         <p:spPr>
-          <a:xfrm rot="16200000" flipH="1">
-            <a:off x="4785860" y="4378397"/>
-            <a:ext cx="1475687" cy="791062"/>
-          </a:xfrm>
-          <a:prstGeom prst="bentConnector3">
-            <a:avLst>
-              <a:gd name="adj1" fmla="val 76851"/>
-            </a:avLst>
+          <a:xfrm>
+            <a:off x="5917246" y="5468036"/>
+            <a:ext cx="2839404" cy="0"/>
+          </a:xfrm>
+          <a:prstGeom prst="straightConnector1">
+            <a:avLst/>
           </a:prstGeom>
           <a:ln>
             <a:tailEnd type="triangle"/>
@@ -3998,10 +5041,129 @@
       </p:cxnSp>
       <p:sp>
         <p:nvSpPr>
-          <p:cNvPr id="22" name="Oval 21">
-            <a:extLst>
-              <a:ext uri="{FF2B5EF4-FFF2-40B4-BE49-F238E27FC236}">
-                <a16:creationId xmlns:a16="http://schemas.microsoft.com/office/drawing/2014/main" id="{70A64918-8EC4-1005-D578-89B5B312CB7B}"/>
+          <p:cNvPr id="84" name="TextBox 83">
+            <a:extLst>
+              <a:ext uri="{FF2B5EF4-FFF2-40B4-BE49-F238E27FC236}">
+                <a16:creationId xmlns:a16="http://schemas.microsoft.com/office/drawing/2014/main" id="{D7818126-AFEA-EB27-CB8D-4E7685F6B3AF}"/>
+              </a:ext>
+            </a:extLst>
+          </p:cNvPr>
+          <p:cNvSpPr txBox="1"/>
+          <p:nvPr/>
+        </p:nvSpPr>
+        <p:spPr>
+          <a:xfrm>
+            <a:off x="970151" y="4842327"/>
+            <a:ext cx="2502641" cy="1200329"/>
+          </a:xfrm>
+          <a:prstGeom prst="rect">
+            <a:avLst/>
+          </a:prstGeom>
+          <a:noFill/>
+        </p:spPr>
+        <p:txBody>
+          <a:bodyPr wrap="square" rtlCol="0">
+            <a:spAutoFit/>
+          </a:bodyPr>
+          <a:lstStyle/>
+          <a:p>
+            <a:pPr marL="171450" indent="-171450">
+              <a:buFontTx/>
+              <a:buChar char="-"/>
+            </a:pPr>
+            <a:r>
+              <a:rPr lang="en-US" sz="1200" dirty="0">
+                <a:solidFill>
+                  <a:schemeClr val="bg1">
+                    <a:lumMod val="50000"/>
+                  </a:schemeClr>
+                </a:solidFill>
+              </a:rPr>
+              <a:t>Determine input format &amp; which translate tool to use</a:t>
+            </a:r>
+          </a:p>
+          <a:p>
+            <a:pPr marL="171450" indent="-171450">
+              <a:buFontTx/>
+              <a:buChar char="-"/>
+            </a:pPr>
+            <a:r>
+              <a:rPr lang="en-US" sz="1200" dirty="0">
+                <a:solidFill>
+                  <a:schemeClr val="bg1">
+                    <a:lumMod val="50000"/>
+                  </a:schemeClr>
+                </a:solidFill>
+              </a:rPr>
+              <a:t>Determine query to pass to RAG search</a:t>
+            </a:r>
+          </a:p>
+          <a:p>
+            <a:pPr marL="171450" indent="-171450">
+              <a:buFontTx/>
+              <a:buChar char="-"/>
+            </a:pPr>
+            <a:r>
+              <a:rPr lang="en-US" sz="1200" dirty="0">
+                <a:solidFill>
+                  <a:schemeClr val="bg1">
+                    <a:lumMod val="50000"/>
+                  </a:schemeClr>
+                </a:solidFill>
+              </a:rPr>
+              <a:t>Determine query to pass to literature search</a:t>
+            </a:r>
+          </a:p>
+        </p:txBody>
+      </p:sp>
+      <p:sp>
+        <p:nvSpPr>
+          <p:cNvPr id="85" name="TextBox 84">
+            <a:extLst>
+              <a:ext uri="{FF2B5EF4-FFF2-40B4-BE49-F238E27FC236}">
+                <a16:creationId xmlns:a16="http://schemas.microsoft.com/office/drawing/2014/main" id="{A4E700CE-7CB7-1994-D47F-471DA5E1A4DD}"/>
+              </a:ext>
+            </a:extLst>
+          </p:cNvPr>
+          <p:cNvSpPr txBox="1"/>
+          <p:nvPr/>
+        </p:nvSpPr>
+        <p:spPr>
+          <a:xfrm>
+            <a:off x="5739516" y="2264431"/>
+            <a:ext cx="1864228" cy="461665"/>
+          </a:xfrm>
+          <a:prstGeom prst="rect">
+            <a:avLst/>
+          </a:prstGeom>
+          <a:noFill/>
+        </p:spPr>
+        <p:txBody>
+          <a:bodyPr wrap="square" rtlCol="0">
+            <a:spAutoFit/>
+          </a:bodyPr>
+          <a:lstStyle/>
+          <a:p>
+            <a:pPr algn="ctr"/>
+            <a:r>
+              <a:rPr lang="en-US" sz="1200" dirty="0">
+                <a:solidFill>
+                  <a:schemeClr val="bg1">
+                    <a:lumMod val="50000"/>
+                  </a:schemeClr>
+                </a:solidFill>
+              </a:rPr>
+              <a:t>All necessary tools are decided in one step</a:t>
+            </a:r>
+          </a:p>
+        </p:txBody>
+      </p:sp>
+      <p:sp>
+        <p:nvSpPr>
+          <p:cNvPr id="105" name="Rectangle 104">
+            <a:extLst>
+              <a:ext uri="{FF2B5EF4-FFF2-40B4-BE49-F238E27FC236}">
+                <a16:creationId xmlns:a16="http://schemas.microsoft.com/office/drawing/2014/main" id="{668C1652-05CA-E04D-7694-3BCE7391F791}"/>
               </a:ext>
             </a:extLst>
           </p:cNvPr>
@@ -4010,24 +5172,33 @@
         </p:nvSpPr>
         <p:spPr>
           <a:xfrm>
-            <a:off x="7592621" y="2030156"/>
-            <a:ext cx="1466053" cy="1214176"/>
-          </a:xfrm>
-          <a:prstGeom prst="ellipse">
+            <a:off x="4584224" y="499288"/>
+            <a:ext cx="4181246" cy="344548"/>
+          </a:xfrm>
+          <a:prstGeom prst="rect">
             <a:avLst/>
           </a:prstGeom>
+          <a:solidFill>
+            <a:schemeClr val="accent5">
+              <a:lumMod val="20000"/>
+              <a:lumOff val="80000"/>
+            </a:schemeClr>
+          </a:solidFill>
+          <a:ln>
+            <a:noFill/>
+          </a:ln>
         </p:spPr>
         <p:style>
           <a:lnRef idx="2">
-            <a:schemeClr val="accent2">
+            <a:schemeClr val="accent1">
               <a:shade val="15000"/>
             </a:schemeClr>
           </a:lnRef>
           <a:fillRef idx="1">
-            <a:schemeClr val="accent2"/>
+            <a:schemeClr val="accent1"/>
           </a:fillRef>
           <a:effectRef idx="0">
-            <a:schemeClr val="accent2"/>
+            <a:schemeClr val="accent1"/>
           </a:effectRef>
           <a:fontRef idx="minor">
             <a:schemeClr val="lt1"/>
@@ -4039,25 +5210,22 @@
           <a:p>
             <a:pPr algn="ctr"/>
             <a:r>
-              <a:rPr lang="en-US" sz="1200" dirty="0"/>
-              <a:t>RAG search</a:t>
-            </a:r>
-          </a:p>
-          <a:p>
-            <a:pPr algn="ctr"/>
-            <a:r>
-              <a:rPr lang="en-US" sz="1200" dirty="0"/>
-              <a:t>deliberation stage</a:t>
-            </a:r>
-          </a:p>
-        </p:txBody>
-      </p:sp>
-      <p:sp>
-        <p:nvSpPr>
-          <p:cNvPr id="29" name="Oval 28">
-            <a:extLst>
-              <a:ext uri="{FF2B5EF4-FFF2-40B4-BE49-F238E27FC236}">
-                <a16:creationId xmlns:a16="http://schemas.microsoft.com/office/drawing/2014/main" id="{6FAF0A76-AA77-DEE7-8E72-17BEC45C5AF1}"/>
+              <a:rPr lang="en-US" dirty="0">
+                <a:solidFill>
+                  <a:schemeClr val="tx1"/>
+                </a:solidFill>
+              </a:rPr>
+              <a:t>Tools memory</a:t>
+            </a:r>
+          </a:p>
+        </p:txBody>
+      </p:sp>
+      <p:sp>
+        <p:nvSpPr>
+          <p:cNvPr id="107" name="Rectangle 106">
+            <a:extLst>
+              <a:ext uri="{FF2B5EF4-FFF2-40B4-BE49-F238E27FC236}">
+                <a16:creationId xmlns:a16="http://schemas.microsoft.com/office/drawing/2014/main" id="{F1B9536B-FD03-402F-E769-FA31EFF5139A}"/>
               </a:ext>
             </a:extLst>
           </p:cNvPr>
@@ -4066,24 +5234,33 @@
         </p:nvSpPr>
         <p:spPr>
           <a:xfrm>
-            <a:off x="9119524" y="2030156"/>
-            <a:ext cx="1466053" cy="1214176"/>
-          </a:xfrm>
-          <a:prstGeom prst="ellipse">
+            <a:off x="4577789" y="890296"/>
+            <a:ext cx="4181246" cy="344548"/>
+          </a:xfrm>
+          <a:prstGeom prst="rect">
             <a:avLst/>
           </a:prstGeom>
+          <a:solidFill>
+            <a:schemeClr val="accent2">
+              <a:lumMod val="20000"/>
+              <a:lumOff val="80000"/>
+            </a:schemeClr>
+          </a:solidFill>
+          <a:ln>
+            <a:noFill/>
+          </a:ln>
         </p:spPr>
         <p:style>
           <a:lnRef idx="2">
-            <a:schemeClr val="accent6">
+            <a:schemeClr val="accent1">
               <a:shade val="15000"/>
             </a:schemeClr>
           </a:lnRef>
           <a:fillRef idx="1">
-            <a:schemeClr val="accent6"/>
+            <a:schemeClr val="accent1"/>
           </a:fillRef>
           <a:effectRef idx="0">
-            <a:schemeClr val="accent6"/>
+            <a:schemeClr val="accent1"/>
           </a:effectRef>
           <a:fontRef idx="minor">
             <a:schemeClr val="lt1"/>
@@ -4095,649 +5272,57 @@
           <a:p>
             <a:pPr algn="ctr"/>
             <a:r>
-              <a:rPr lang="en-US" sz="1200" dirty="0"/>
-              <a:t>Literature search</a:t>
-            </a:r>
-          </a:p>
-          <a:p>
-            <a:pPr algn="ctr"/>
-            <a:r>
-              <a:rPr lang="en-US" sz="1200" dirty="0"/>
-              <a:t>deliberation stage</a:t>
-            </a:r>
-          </a:p>
-        </p:txBody>
-      </p:sp>
-      <p:cxnSp>
-        <p:nvCxnSpPr>
-          <p:cNvPr id="41" name="Connector: Elbow 40">
-            <a:extLst>
-              <a:ext uri="{FF2B5EF4-FFF2-40B4-BE49-F238E27FC236}">
-                <a16:creationId xmlns:a16="http://schemas.microsoft.com/office/drawing/2014/main" id="{D7F0EA3F-A81B-21DC-5514-6B4CB7B3A84B}"/>
-              </a:ext>
-            </a:extLst>
-          </p:cNvPr>
-          <p:cNvCxnSpPr>
-            <a:cxnSpLocks/>
-            <a:stCxn id="44" idx="0"/>
-            <a:endCxn id="22" idx="0"/>
-          </p:cNvCxnSpPr>
+              <a:rPr lang="en-US" dirty="0">
+                <a:solidFill>
+                  <a:schemeClr val="tx1"/>
+                </a:solidFill>
+              </a:rPr>
+              <a:t>RAG memory</a:t>
+            </a:r>
+          </a:p>
+        </p:txBody>
+      </p:sp>
+      <p:sp>
+        <p:nvSpPr>
+          <p:cNvPr id="108" name="Rectangle 107">
+            <a:extLst>
+              <a:ext uri="{FF2B5EF4-FFF2-40B4-BE49-F238E27FC236}">
+                <a16:creationId xmlns:a16="http://schemas.microsoft.com/office/drawing/2014/main" id="{33C40FF2-7066-3F25-97C5-BF5EECFD1017}"/>
+              </a:ext>
+            </a:extLst>
+          </p:cNvPr>
+          <p:cNvSpPr/>
           <p:nvPr/>
-        </p:nvCxnSpPr>
-        <p:spPr>
-          <a:xfrm rot="5400000" flipH="1" flipV="1">
-            <a:off x="6331034" y="827295"/>
-            <a:ext cx="791753" cy="3197476"/>
-          </a:xfrm>
-          <a:prstGeom prst="bentConnector3">
-            <a:avLst>
-              <a:gd name="adj1" fmla="val 128873"/>
-            </a:avLst>
-          </a:prstGeom>
-          <a:ln>
-            <a:tailEnd type="triangle"/>
-          </a:ln>
-        </p:spPr>
-        <p:style>
-          <a:lnRef idx="2">
-            <a:schemeClr val="dk1"/>
-          </a:lnRef>
-          <a:fillRef idx="0">
-            <a:schemeClr val="dk1"/>
-          </a:fillRef>
-          <a:effectRef idx="1">
-            <a:schemeClr val="dk1"/>
-          </a:effectRef>
-          <a:fontRef idx="minor">
-            <a:schemeClr val="tx1"/>
-          </a:fontRef>
-        </p:style>
-      </p:cxnSp>
-      <p:cxnSp>
-        <p:nvCxnSpPr>
-          <p:cNvPr id="49" name="Connector: Elbow 48">
-            <a:extLst>
-              <a:ext uri="{FF2B5EF4-FFF2-40B4-BE49-F238E27FC236}">
-                <a16:creationId xmlns:a16="http://schemas.microsoft.com/office/drawing/2014/main" id="{8FE466A4-3AC7-A35B-2C31-A3FE51D4E122}"/>
-              </a:ext>
-            </a:extLst>
-          </p:cNvPr>
-          <p:cNvCxnSpPr>
-            <a:cxnSpLocks/>
-            <a:stCxn id="22" idx="0"/>
-            <a:endCxn id="29" idx="0"/>
-          </p:cNvCxnSpPr>
-          <p:nvPr/>
-        </p:nvCxnSpPr>
-        <p:spPr>
-          <a:xfrm rot="5400000" flipH="1" flipV="1">
-            <a:off x="9089099" y="1266705"/>
-            <a:ext cx="12700" cy="1526903"/>
-          </a:xfrm>
-          <a:prstGeom prst="bentConnector3">
-            <a:avLst>
-              <a:gd name="adj1" fmla="val 1847677"/>
-            </a:avLst>
-          </a:prstGeom>
-          <a:ln>
-            <a:tailEnd type="triangle"/>
-          </a:ln>
-        </p:spPr>
-        <p:style>
-          <a:lnRef idx="2">
-            <a:schemeClr val="dk1"/>
-          </a:lnRef>
-          <a:fillRef idx="0">
-            <a:schemeClr val="dk1"/>
-          </a:fillRef>
-          <a:effectRef idx="1">
-            <a:schemeClr val="dk1"/>
-          </a:effectRef>
-          <a:fontRef idx="minor">
-            <a:schemeClr val="tx1"/>
-          </a:fontRef>
-        </p:style>
-      </p:cxnSp>
-      <p:cxnSp>
-        <p:nvCxnSpPr>
-          <p:cNvPr id="53" name="Connector: Elbow 52">
-            <a:extLst>
-              <a:ext uri="{FF2B5EF4-FFF2-40B4-BE49-F238E27FC236}">
-                <a16:creationId xmlns:a16="http://schemas.microsoft.com/office/drawing/2014/main" id="{15591700-A4D0-FCEE-F470-4F771DC37AA6}"/>
-              </a:ext>
-            </a:extLst>
-          </p:cNvPr>
-          <p:cNvCxnSpPr>
-            <a:cxnSpLocks/>
-            <a:stCxn id="29" idx="0"/>
-            <a:endCxn id="31" idx="0"/>
-          </p:cNvCxnSpPr>
-          <p:nvPr/>
-        </p:nvCxnSpPr>
-        <p:spPr>
-          <a:xfrm rot="5400000" flipH="1" flipV="1">
-            <a:off x="10624548" y="1258159"/>
-            <a:ext cx="12700" cy="1543995"/>
-          </a:xfrm>
-          <a:prstGeom prst="bentConnector3">
-            <a:avLst>
-              <a:gd name="adj1" fmla="val 1847685"/>
-            </a:avLst>
-          </a:prstGeom>
-          <a:ln>
-            <a:tailEnd type="triangle"/>
-          </a:ln>
-        </p:spPr>
-        <p:style>
-          <a:lnRef idx="2">
-            <a:schemeClr val="dk1"/>
-          </a:lnRef>
-          <a:fillRef idx="0">
-            <a:schemeClr val="dk1"/>
-          </a:fillRef>
-          <a:effectRef idx="1">
-            <a:schemeClr val="dk1"/>
-          </a:effectRef>
-          <a:fontRef idx="minor">
-            <a:schemeClr val="tx1"/>
-          </a:fontRef>
-        </p:style>
-      </p:cxnSp>
-      <p:cxnSp>
-        <p:nvCxnSpPr>
-          <p:cNvPr id="59" name="Straight Arrow Connector 58">
-            <a:extLst>
-              <a:ext uri="{FF2B5EF4-FFF2-40B4-BE49-F238E27FC236}">
-                <a16:creationId xmlns:a16="http://schemas.microsoft.com/office/drawing/2014/main" id="{6E6A970C-60C6-8E3C-9119-0B974E524830}"/>
-              </a:ext>
-            </a:extLst>
-          </p:cNvPr>
-          <p:cNvCxnSpPr>
-            <a:cxnSpLocks/>
-            <a:stCxn id="22" idx="4"/>
-            <a:endCxn id="24" idx="0"/>
-          </p:cNvCxnSpPr>
-          <p:nvPr/>
-        </p:nvCxnSpPr>
-        <p:spPr>
-          <a:xfrm flipH="1">
-            <a:off x="8325647" y="3244332"/>
-            <a:ext cx="1" cy="222564"/>
-          </a:xfrm>
-          <a:prstGeom prst="straightConnector1">
-            <a:avLst/>
-          </a:prstGeom>
-          <a:ln>
-            <a:tailEnd type="triangle"/>
-          </a:ln>
-        </p:spPr>
-        <p:style>
-          <a:lnRef idx="2">
-            <a:schemeClr val="dk1"/>
-          </a:lnRef>
-          <a:fillRef idx="0">
-            <a:schemeClr val="dk1"/>
-          </a:fillRef>
-          <a:effectRef idx="1">
-            <a:schemeClr val="dk1"/>
-          </a:effectRef>
-          <a:fontRef idx="minor">
-            <a:schemeClr val="tx1"/>
-          </a:fontRef>
-        </p:style>
-      </p:cxnSp>
-      <p:cxnSp>
-        <p:nvCxnSpPr>
-          <p:cNvPr id="65" name="Straight Arrow Connector 64">
-            <a:extLst>
-              <a:ext uri="{FF2B5EF4-FFF2-40B4-BE49-F238E27FC236}">
-                <a16:creationId xmlns:a16="http://schemas.microsoft.com/office/drawing/2014/main" id="{443E7F0B-8504-34EC-96EA-0E91F5093D14}"/>
-              </a:ext>
-            </a:extLst>
-          </p:cNvPr>
-          <p:cNvCxnSpPr>
-            <a:cxnSpLocks/>
-            <a:stCxn id="29" idx="4"/>
-            <a:endCxn id="28" idx="0"/>
-          </p:cNvCxnSpPr>
-          <p:nvPr/>
-        </p:nvCxnSpPr>
-        <p:spPr>
-          <a:xfrm flipH="1">
-            <a:off x="9852550" y="3244332"/>
-            <a:ext cx="1" cy="222564"/>
-          </a:xfrm>
-          <a:prstGeom prst="straightConnector1">
-            <a:avLst/>
-          </a:prstGeom>
-          <a:ln>
-            <a:tailEnd type="triangle"/>
-          </a:ln>
-        </p:spPr>
-        <p:style>
-          <a:lnRef idx="2">
-            <a:schemeClr val="dk1"/>
-          </a:lnRef>
-          <a:fillRef idx="0">
-            <a:schemeClr val="dk1"/>
-          </a:fillRef>
-          <a:effectRef idx="1">
-            <a:schemeClr val="dk1"/>
-          </a:effectRef>
-          <a:fontRef idx="minor">
-            <a:schemeClr val="tx1"/>
-          </a:fontRef>
-        </p:style>
-      </p:cxnSp>
-      <p:cxnSp>
-        <p:nvCxnSpPr>
-          <p:cNvPr id="86" name="Connector: Elbow 85">
-            <a:extLst>
-              <a:ext uri="{FF2B5EF4-FFF2-40B4-BE49-F238E27FC236}">
-                <a16:creationId xmlns:a16="http://schemas.microsoft.com/office/drawing/2014/main" id="{78AD2A00-7B24-59B9-C535-5E7578862B53}"/>
-              </a:ext>
-            </a:extLst>
-          </p:cNvPr>
-          <p:cNvCxnSpPr>
-            <a:cxnSpLocks/>
-            <a:stCxn id="31" idx="4"/>
-            <a:endCxn id="18" idx="6"/>
-          </p:cNvCxnSpPr>
-          <p:nvPr/>
-        </p:nvCxnSpPr>
-        <p:spPr>
-          <a:xfrm rot="5400000">
-            <a:off x="7587139" y="2309453"/>
-            <a:ext cx="2874528" cy="4744286"/>
-          </a:xfrm>
-          <a:prstGeom prst="bentConnector2">
-            <a:avLst/>
-          </a:prstGeom>
-          <a:ln>
-            <a:tailEnd type="triangle"/>
-          </a:ln>
-        </p:spPr>
-        <p:style>
-          <a:lnRef idx="2">
-            <a:schemeClr val="dk1"/>
-          </a:lnRef>
-          <a:fillRef idx="0">
-            <a:schemeClr val="dk1"/>
-          </a:fillRef>
-          <a:effectRef idx="1">
-            <a:schemeClr val="dk1"/>
-          </a:effectRef>
-          <a:fontRef idx="minor">
-            <a:schemeClr val="tx1"/>
-          </a:fontRef>
-        </p:style>
-      </p:cxnSp>
-      <p:cxnSp>
-        <p:nvCxnSpPr>
-          <p:cNvPr id="89" name="Connector: Elbow 88">
-            <a:extLst>
-              <a:ext uri="{FF2B5EF4-FFF2-40B4-BE49-F238E27FC236}">
-                <a16:creationId xmlns:a16="http://schemas.microsoft.com/office/drawing/2014/main" id="{9FA865A2-136D-167C-92A0-FEB2F1D2B877}"/>
-              </a:ext>
-            </a:extLst>
-          </p:cNvPr>
-          <p:cNvCxnSpPr>
-            <a:cxnSpLocks/>
-            <a:stCxn id="29" idx="6"/>
-            <a:endCxn id="18" idx="6"/>
-          </p:cNvCxnSpPr>
-          <p:nvPr/>
-        </p:nvCxnSpPr>
-        <p:spPr>
-          <a:xfrm flipH="1">
-            <a:off x="6652260" y="2637244"/>
-            <a:ext cx="3933317" cy="3481616"/>
-          </a:xfrm>
-          <a:prstGeom prst="bentConnector3">
-            <a:avLst>
-              <a:gd name="adj1" fmla="val -1193"/>
-            </a:avLst>
-          </a:prstGeom>
-          <a:ln>
-            <a:tailEnd type="triangle"/>
-          </a:ln>
-        </p:spPr>
-        <p:style>
-          <a:lnRef idx="2">
-            <a:schemeClr val="dk1"/>
-          </a:lnRef>
-          <a:fillRef idx="0">
-            <a:schemeClr val="dk1"/>
-          </a:fillRef>
-          <a:effectRef idx="1">
-            <a:schemeClr val="dk1"/>
-          </a:effectRef>
-          <a:fontRef idx="minor">
-            <a:schemeClr val="tx1"/>
-          </a:fontRef>
-        </p:style>
-      </p:cxnSp>
-      <p:cxnSp>
-        <p:nvCxnSpPr>
-          <p:cNvPr id="94" name="Connector: Elbow 93">
-            <a:extLst>
-              <a:ext uri="{FF2B5EF4-FFF2-40B4-BE49-F238E27FC236}">
-                <a16:creationId xmlns:a16="http://schemas.microsoft.com/office/drawing/2014/main" id="{412844E8-6E44-28E4-9F6D-81CBBB91066E}"/>
-              </a:ext>
-            </a:extLst>
-          </p:cNvPr>
-          <p:cNvCxnSpPr>
-            <a:cxnSpLocks/>
-            <a:stCxn id="22" idx="6"/>
-            <a:endCxn id="18" idx="6"/>
-          </p:cNvCxnSpPr>
-          <p:nvPr/>
-        </p:nvCxnSpPr>
-        <p:spPr>
-          <a:xfrm flipH="1">
-            <a:off x="6652260" y="2637244"/>
-            <a:ext cx="2406414" cy="3481616"/>
-          </a:xfrm>
-          <a:prstGeom prst="bentConnector3">
-            <a:avLst>
-              <a:gd name="adj1" fmla="val -1447"/>
-            </a:avLst>
-          </a:prstGeom>
-          <a:ln>
-            <a:tailEnd type="triangle"/>
-          </a:ln>
-        </p:spPr>
-        <p:style>
-          <a:lnRef idx="2">
-            <a:schemeClr val="dk1"/>
-          </a:lnRef>
-          <a:fillRef idx="0">
-            <a:schemeClr val="dk1"/>
-          </a:fillRef>
-          <a:effectRef idx="1">
-            <a:schemeClr val="dk1"/>
-          </a:effectRef>
-          <a:fontRef idx="minor">
-            <a:schemeClr val="tx1"/>
-          </a:fontRef>
-        </p:style>
-      </p:cxnSp>
-      <p:cxnSp>
-        <p:nvCxnSpPr>
-          <p:cNvPr id="98" name="Connector: Elbow 97">
-            <a:extLst>
-              <a:ext uri="{FF2B5EF4-FFF2-40B4-BE49-F238E27FC236}">
-                <a16:creationId xmlns:a16="http://schemas.microsoft.com/office/drawing/2014/main" id="{3CA0C529-8BB7-1450-ECEA-D4B55D1689E6}"/>
-              </a:ext>
-            </a:extLst>
-          </p:cNvPr>
-          <p:cNvCxnSpPr>
-            <a:cxnSpLocks/>
-            <a:stCxn id="4" idx="0"/>
-            <a:endCxn id="22" idx="0"/>
-          </p:cNvCxnSpPr>
-          <p:nvPr/>
-        </p:nvCxnSpPr>
-        <p:spPr>
-          <a:xfrm rot="5400000" flipH="1" flipV="1">
-            <a:off x="4499973" y="-1003765"/>
-            <a:ext cx="791754" cy="6859596"/>
-          </a:xfrm>
-          <a:prstGeom prst="bentConnector3">
-            <a:avLst>
-              <a:gd name="adj1" fmla="val 128873"/>
-            </a:avLst>
-          </a:prstGeom>
-          <a:ln>
-            <a:tailEnd type="triangle"/>
-          </a:ln>
-        </p:spPr>
-        <p:style>
-          <a:lnRef idx="2">
-            <a:schemeClr val="dk1"/>
-          </a:lnRef>
-          <a:fillRef idx="0">
-            <a:schemeClr val="dk1"/>
-          </a:fillRef>
-          <a:effectRef idx="1">
-            <a:schemeClr val="dk1"/>
-          </a:effectRef>
-          <a:fontRef idx="minor">
-            <a:schemeClr val="tx1"/>
-          </a:fontRef>
-        </p:style>
-      </p:cxnSp>
-      <p:sp>
-        <p:nvSpPr>
-          <p:cNvPr id="101" name="TextBox 100">
-            <a:extLst>
-              <a:ext uri="{FF2B5EF4-FFF2-40B4-BE49-F238E27FC236}">
-                <a16:creationId xmlns:a16="http://schemas.microsoft.com/office/drawing/2014/main" id="{A52F3018-8359-78D3-0BA7-68FADE25F530}"/>
-              </a:ext>
-            </a:extLst>
-          </p:cNvPr>
-          <p:cNvSpPr txBox="1"/>
-          <p:nvPr/>
-        </p:nvSpPr>
-        <p:spPr>
-          <a:xfrm>
-            <a:off x="1321193" y="1423068"/>
-            <a:ext cx="5185330" cy="369332"/>
+        </p:nvSpPr>
+        <p:spPr>
+          <a:xfrm>
+            <a:off x="4581006" y="1288393"/>
+            <a:ext cx="4181246" cy="344548"/>
           </a:xfrm>
           <a:prstGeom prst="rect">
             <a:avLst/>
           </a:prstGeom>
-          <a:noFill/>
-        </p:spPr>
-        <p:txBody>
-          <a:bodyPr wrap="none" rtlCol="0">
-            <a:spAutoFit/>
-          </a:bodyPr>
-          <a:lstStyle/>
-          <a:p>
-            <a:r>
-              <a:rPr lang="en-US" dirty="0"/>
-              <a:t>If asked directly to perform a RAG/literature search</a:t>
-            </a:r>
-          </a:p>
-        </p:txBody>
-      </p:sp>
-      <p:sp>
-        <p:nvSpPr>
-          <p:cNvPr id="102" name="TextBox 101">
-            <a:extLst>
-              <a:ext uri="{FF2B5EF4-FFF2-40B4-BE49-F238E27FC236}">
-                <a16:creationId xmlns:a16="http://schemas.microsoft.com/office/drawing/2014/main" id="{DDBCA147-35A9-479F-2420-83DE35EFB588}"/>
-              </a:ext>
-            </a:extLst>
-          </p:cNvPr>
-          <p:cNvSpPr txBox="1"/>
-          <p:nvPr/>
-        </p:nvSpPr>
-        <p:spPr>
-          <a:xfrm>
-            <a:off x="6796051" y="6083044"/>
-            <a:ext cx="4295791" cy="369332"/>
-          </a:xfrm>
-          <a:prstGeom prst="rect">
-            <a:avLst/>
-          </a:prstGeom>
-          <a:noFill/>
-        </p:spPr>
-        <p:txBody>
-          <a:bodyPr wrap="none" rtlCol="0">
-            <a:spAutoFit/>
-          </a:bodyPr>
-          <a:lstStyle/>
-          <a:p>
-            <a:r>
-              <a:rPr lang="en-US" dirty="0"/>
-              <a:t>If the response answers the original query</a:t>
-            </a:r>
-          </a:p>
-        </p:txBody>
-      </p:sp>
-      <p:sp>
-        <p:nvSpPr>
-          <p:cNvPr id="103" name="TextBox 102">
-            <a:extLst>
-              <a:ext uri="{FF2B5EF4-FFF2-40B4-BE49-F238E27FC236}">
-                <a16:creationId xmlns:a16="http://schemas.microsoft.com/office/drawing/2014/main" id="{3667054A-044E-1710-0F3D-BAC35B844B49}"/>
-              </a:ext>
-            </a:extLst>
-          </p:cNvPr>
-          <p:cNvSpPr txBox="1"/>
-          <p:nvPr/>
-        </p:nvSpPr>
-        <p:spPr>
-          <a:xfrm>
-            <a:off x="5634476" y="1746303"/>
-            <a:ext cx="2361031" cy="646331"/>
-          </a:xfrm>
-          <a:prstGeom prst="rect">
-            <a:avLst/>
-          </a:prstGeom>
-          <a:noFill/>
-        </p:spPr>
-        <p:txBody>
-          <a:bodyPr wrap="none" rtlCol="0">
-            <a:spAutoFit/>
-          </a:bodyPr>
-          <a:lstStyle/>
-          <a:p>
-            <a:r>
-              <a:rPr lang="en-US" dirty="0"/>
-              <a:t>If the tools’ responses</a:t>
-            </a:r>
-          </a:p>
-          <a:p>
-            <a:r>
-              <a:rPr lang="en-US" dirty="0"/>
-              <a:t>are insufficient</a:t>
-            </a:r>
-          </a:p>
-        </p:txBody>
-      </p:sp>
-      <p:sp>
-        <p:nvSpPr>
-          <p:cNvPr id="104" name="TextBox 103">
-            <a:extLst>
-              <a:ext uri="{FF2B5EF4-FFF2-40B4-BE49-F238E27FC236}">
-                <a16:creationId xmlns:a16="http://schemas.microsoft.com/office/drawing/2014/main" id="{D19A34CE-C062-284C-5932-A228F82AF342}"/>
-              </a:ext>
-            </a:extLst>
-          </p:cNvPr>
-          <p:cNvSpPr txBox="1"/>
-          <p:nvPr/>
-        </p:nvSpPr>
-        <p:spPr>
-          <a:xfrm>
-            <a:off x="2652372" y="4378052"/>
-            <a:ext cx="2533835" cy="646331"/>
-          </a:xfrm>
-          <a:prstGeom prst="rect">
-            <a:avLst/>
-          </a:prstGeom>
-          <a:noFill/>
-        </p:spPr>
-        <p:txBody>
-          <a:bodyPr wrap="none" rtlCol="0">
-            <a:spAutoFit/>
-          </a:bodyPr>
-          <a:lstStyle/>
-          <a:p>
-            <a:r>
-              <a:rPr lang="en-US" dirty="0"/>
-              <a:t>If the response answers</a:t>
-            </a:r>
-          </a:p>
-          <a:p>
-            <a:r>
-              <a:rPr lang="en-US" dirty="0"/>
-              <a:t>the original query</a:t>
-            </a:r>
-          </a:p>
-        </p:txBody>
-      </p:sp>
-      <p:sp>
-        <p:nvSpPr>
-          <p:cNvPr id="2" name="TextBox 1">
-            <a:extLst>
-              <a:ext uri="{FF2B5EF4-FFF2-40B4-BE49-F238E27FC236}">
-                <a16:creationId xmlns:a16="http://schemas.microsoft.com/office/drawing/2014/main" id="{FC91ECF9-9982-A616-45C9-7BF7B569E5D9}"/>
-              </a:ext>
-            </a:extLst>
-          </p:cNvPr>
-          <p:cNvSpPr txBox="1"/>
-          <p:nvPr/>
-        </p:nvSpPr>
-        <p:spPr>
-          <a:xfrm>
-            <a:off x="2535182" y="2155595"/>
-            <a:ext cx="1976054" cy="646331"/>
-          </a:xfrm>
-          <a:prstGeom prst="rect">
-            <a:avLst/>
-          </a:prstGeom>
-          <a:noFill/>
-        </p:spPr>
-        <p:txBody>
-          <a:bodyPr wrap="none" rtlCol="0">
-            <a:spAutoFit/>
-          </a:bodyPr>
-          <a:lstStyle/>
-          <a:p>
-            <a:r>
-              <a:rPr lang="en-US" dirty="0"/>
-              <a:t>Most tools require</a:t>
-            </a:r>
-          </a:p>
-          <a:p>
-            <a:r>
-              <a:rPr lang="en-US" dirty="0"/>
-              <a:t>DTXSID as input</a:t>
-            </a:r>
-          </a:p>
-        </p:txBody>
-      </p:sp>
-      <p:sp>
-        <p:nvSpPr>
-          <p:cNvPr id="5" name="Rectangle: Rounded Corners 4">
-            <a:extLst>
-              <a:ext uri="{FF2B5EF4-FFF2-40B4-BE49-F238E27FC236}">
-                <a16:creationId xmlns:a16="http://schemas.microsoft.com/office/drawing/2014/main" id="{E4D110DB-9B30-3827-6094-B7ADA210A3AA}"/>
-              </a:ext>
-            </a:extLst>
-          </p:cNvPr>
-          <p:cNvSpPr/>
-          <p:nvPr/>
-        </p:nvSpPr>
-        <p:spPr>
-          <a:xfrm>
-            <a:off x="6170050" y="2602142"/>
-            <a:ext cx="905099" cy="356127"/>
-          </a:xfrm>
-          <a:prstGeom prst="roundRect">
-            <a:avLst/>
-          </a:prstGeom>
           <a:solidFill>
-            <a:schemeClr val="accent5">
-              <a:lumMod val="60000"/>
-              <a:lumOff val="40000"/>
+            <a:schemeClr val="accent6">
+              <a:lumMod val="20000"/>
+              <a:lumOff val="80000"/>
             </a:schemeClr>
           </a:solidFill>
+          <a:ln>
+            <a:noFill/>
+          </a:ln>
         </p:spPr>
         <p:style>
           <a:lnRef idx="2">
-            <a:schemeClr val="accent5">
+            <a:schemeClr val="accent1">
               <a:shade val="15000"/>
             </a:schemeClr>
           </a:lnRef>
           <a:fillRef idx="1">
-            <a:schemeClr val="accent5"/>
+            <a:schemeClr val="accent1"/>
           </a:fillRef>
           <a:effectRef idx="0">
-            <a:schemeClr val="accent5"/>
+            <a:schemeClr val="accent1"/>
           </a:effectRef>
           <a:fontRef idx="minor">
             <a:schemeClr val="lt1"/>
@@ -4749,18 +5334,22 @@
           <a:p>
             <a:pPr algn="ctr"/>
             <a:r>
-              <a:rPr lang="en-US" sz="1200" dirty="0"/>
-              <a:t>Tool call 1</a:t>
-            </a:r>
-          </a:p>
-        </p:txBody>
-      </p:sp>
-      <p:sp>
-        <p:nvSpPr>
-          <p:cNvPr id="8" name="Rectangle: Rounded Corners 7">
-            <a:extLst>
-              <a:ext uri="{FF2B5EF4-FFF2-40B4-BE49-F238E27FC236}">
-                <a16:creationId xmlns:a16="http://schemas.microsoft.com/office/drawing/2014/main" id="{EB029D12-ED00-98A0-D117-D74A0658E6BD}"/>
+              <a:rPr lang="en-US" sz="1200" dirty="0">
+                <a:solidFill>
+                  <a:schemeClr val="tx1"/>
+                </a:solidFill>
+              </a:rPr>
+              <a:t>Literature memory</a:t>
+            </a:r>
+          </a:p>
+        </p:txBody>
+      </p:sp>
+      <p:sp>
+        <p:nvSpPr>
+          <p:cNvPr id="109" name="Rectangle 108">
+            <a:extLst>
+              <a:ext uri="{FF2B5EF4-FFF2-40B4-BE49-F238E27FC236}">
+                <a16:creationId xmlns:a16="http://schemas.microsoft.com/office/drawing/2014/main" id="{3081C72B-1D49-9FAB-C664-478682CE91F9}"/>
               </a:ext>
             </a:extLst>
           </p:cNvPr>
@@ -4769,24 +5358,32 @@
         </p:nvSpPr>
         <p:spPr>
           <a:xfrm>
-            <a:off x="6170050" y="3063710"/>
-            <a:ext cx="905099" cy="356127"/>
-          </a:xfrm>
-          <a:prstGeom prst="roundRect">
+            <a:off x="4570328" y="1684273"/>
+            <a:ext cx="4181246" cy="344548"/>
+          </a:xfrm>
+          <a:prstGeom prst="rect">
             <a:avLst/>
           </a:prstGeom>
+          <a:solidFill>
+            <a:schemeClr val="bg1">
+              <a:lumMod val="95000"/>
+            </a:schemeClr>
+          </a:solidFill>
+          <a:ln>
+            <a:noFill/>
+          </a:ln>
         </p:spPr>
         <p:style>
           <a:lnRef idx="2">
-            <a:schemeClr val="accent5">
+            <a:schemeClr val="accent1">
               <a:shade val="15000"/>
             </a:schemeClr>
           </a:lnRef>
           <a:fillRef idx="1">
-            <a:schemeClr val="accent5"/>
+            <a:schemeClr val="accent1"/>
           </a:fillRef>
           <a:effectRef idx="0">
-            <a:schemeClr val="accent5"/>
+            <a:schemeClr val="accent1"/>
           </a:effectRef>
           <a:fontRef idx="minor">
             <a:schemeClr val="lt1"/>
@@ -4798,148 +5395,48 @@
           <a:p>
             <a:pPr algn="ctr"/>
             <a:r>
-              <a:rPr lang="en-US" sz="1200" dirty="0"/>
-              <a:t>Tool call 2</a:t>
-            </a:r>
-          </a:p>
-        </p:txBody>
-      </p:sp>
-      <p:sp>
-        <p:nvSpPr>
-          <p:cNvPr id="9" name="Rectangle: Rounded Corners 8">
-            <a:extLst>
-              <a:ext uri="{FF2B5EF4-FFF2-40B4-BE49-F238E27FC236}">
-                <a16:creationId xmlns:a16="http://schemas.microsoft.com/office/drawing/2014/main" id="{0D86D933-D9DB-2F75-4DB4-F9A0259CC04E}"/>
-              </a:ext>
-            </a:extLst>
-          </p:cNvPr>
-          <p:cNvSpPr/>
+              <a:rPr lang="en-US" dirty="0">
+                <a:solidFill>
+                  <a:schemeClr val="tx1"/>
+                </a:solidFill>
+              </a:rPr>
+              <a:t>Main memory</a:t>
+            </a:r>
+          </a:p>
+        </p:txBody>
+      </p:sp>
+      <p:cxnSp>
+        <p:nvCxnSpPr>
+          <p:cNvPr id="111" name="Connector: Elbow 110">
+            <a:extLst>
+              <a:ext uri="{FF2B5EF4-FFF2-40B4-BE49-F238E27FC236}">
+                <a16:creationId xmlns:a16="http://schemas.microsoft.com/office/drawing/2014/main" id="{22DEFF10-1C30-6F7B-3067-BE08A39FCE97}"/>
+              </a:ext>
+            </a:extLst>
+          </p:cNvPr>
+          <p:cNvCxnSpPr>
+            <a:stCxn id="92" idx="0"/>
+            <a:endCxn id="91" idx="0"/>
+          </p:cNvCxnSpPr>
           <p:nvPr/>
-        </p:nvSpPr>
-        <p:spPr>
-          <a:xfrm>
-            <a:off x="6170890" y="3532434"/>
-            <a:ext cx="905099" cy="356127"/>
-          </a:xfrm>
-          <a:prstGeom prst="roundRect">
-            <a:avLst/>
+        </p:nvCxnSpPr>
+        <p:spPr>
+          <a:xfrm rot="16200000" flipV="1">
+            <a:off x="6577747" y="-400464"/>
+            <a:ext cx="12700" cy="7304252"/>
+          </a:xfrm>
+          <a:prstGeom prst="bentConnector3">
+            <a:avLst>
+              <a:gd name="adj1" fmla="val 24050000"/>
+            </a:avLst>
           </a:prstGeom>
-          <a:solidFill>
-            <a:schemeClr val="accent5">
-              <a:lumMod val="75000"/>
-            </a:schemeClr>
-          </a:solidFill>
-        </p:spPr>
-        <p:style>
-          <a:lnRef idx="2">
-            <a:schemeClr val="accent5">
-              <a:shade val="15000"/>
-            </a:schemeClr>
-          </a:lnRef>
-          <a:fillRef idx="1">
-            <a:schemeClr val="accent5"/>
-          </a:fillRef>
-          <a:effectRef idx="0">
-            <a:schemeClr val="accent5"/>
-          </a:effectRef>
-          <a:fontRef idx="minor">
-            <a:schemeClr val="lt1"/>
-          </a:fontRef>
-        </p:style>
-        <p:txBody>
-          <a:bodyPr rtlCol="0" anchor="ctr"/>
-          <a:lstStyle/>
-          <a:p>
-            <a:pPr algn="ctr"/>
-            <a:r>
-              <a:rPr lang="en-US" sz="1200" dirty="0"/>
-              <a:t>…</a:t>
-            </a:r>
-          </a:p>
-        </p:txBody>
-      </p:sp>
-      <p:sp>
-        <p:nvSpPr>
-          <p:cNvPr id="10" name="Rectangle: Rounded Corners 9">
-            <a:extLst>
-              <a:ext uri="{FF2B5EF4-FFF2-40B4-BE49-F238E27FC236}">
-                <a16:creationId xmlns:a16="http://schemas.microsoft.com/office/drawing/2014/main" id="{8D4EB21C-6DFA-A8F1-C39A-3C2940D1BBF2}"/>
-              </a:ext>
-            </a:extLst>
-          </p:cNvPr>
-          <p:cNvSpPr/>
-          <p:nvPr/>
-        </p:nvSpPr>
-        <p:spPr>
-          <a:xfrm>
-            <a:off x="6189032" y="4016749"/>
-            <a:ext cx="905099" cy="356127"/>
-          </a:xfrm>
-          <a:prstGeom prst="roundRect">
-            <a:avLst/>
-          </a:prstGeom>
-          <a:solidFill>
-            <a:schemeClr val="accent5">
-              <a:lumMod val="50000"/>
-            </a:schemeClr>
-          </a:solidFill>
-        </p:spPr>
-        <p:style>
-          <a:lnRef idx="2">
-            <a:schemeClr val="accent5">
-              <a:shade val="15000"/>
-            </a:schemeClr>
-          </a:lnRef>
-          <a:fillRef idx="1">
-            <a:schemeClr val="accent5"/>
-          </a:fillRef>
-          <a:effectRef idx="0">
-            <a:schemeClr val="accent5"/>
-          </a:effectRef>
-          <a:fontRef idx="minor">
-            <a:schemeClr val="lt1"/>
-          </a:fontRef>
-        </p:style>
-        <p:txBody>
-          <a:bodyPr rtlCol="0" anchor="ctr"/>
-          <a:lstStyle/>
-          <a:p>
-            <a:pPr algn="ctr"/>
-            <a:r>
-              <a:rPr lang="en-US" sz="1200" dirty="0"/>
-              <a:t>Tool call </a:t>
-            </a:r>
-            <a:r>
-              <a:rPr lang="en-US" sz="1200" i="1" dirty="0"/>
-              <a:t>N</a:t>
-            </a:r>
-          </a:p>
-        </p:txBody>
-      </p:sp>
-      <p:sp>
-        <p:nvSpPr>
-          <p:cNvPr id="34" name="Right Brace 33">
-            <a:extLst>
-              <a:ext uri="{FF2B5EF4-FFF2-40B4-BE49-F238E27FC236}">
-                <a16:creationId xmlns:a16="http://schemas.microsoft.com/office/drawing/2014/main" id="{EF59F8EB-0C00-A291-4B37-D692C09035DF}"/>
-              </a:ext>
-            </a:extLst>
-          </p:cNvPr>
-          <p:cNvSpPr/>
-          <p:nvPr/>
-        </p:nvSpPr>
-        <p:spPr>
-          <a:xfrm>
-            <a:off x="7144076" y="2602142"/>
-            <a:ext cx="296253" cy="1770734"/>
-          </a:xfrm>
-          <a:prstGeom prst="rightBrace">
-            <a:avLst/>
-          </a:prstGeom>
-          <a:ln>
+          <a:ln w="76200">
             <a:solidFill>
-              <a:schemeClr val="tx1"/>
+              <a:schemeClr val="bg1">
+                <a:lumMod val="95000"/>
+              </a:schemeClr>
             </a:solidFill>
+            <a:tailEnd type="triangle"/>
           </a:ln>
         </p:spPr>
         <p:style>
@@ -4956,250 +5453,7 @@
             <a:schemeClr val="tx1"/>
           </a:fontRef>
         </p:style>
-        <p:txBody>
-          <a:bodyPr rtlCol="0" anchor="ctr"/>
-          <a:lstStyle/>
-          <a:p>
-            <a:pPr algn="ctr"/>
-            <a:endParaRPr lang="en-US"/>
-          </a:p>
-        </p:txBody>
-      </p:sp>
-      <p:sp>
-        <p:nvSpPr>
-          <p:cNvPr id="38" name="Left Brace 37">
-            <a:extLst>
-              <a:ext uri="{FF2B5EF4-FFF2-40B4-BE49-F238E27FC236}">
-                <a16:creationId xmlns:a16="http://schemas.microsoft.com/office/drawing/2014/main" id="{2EDC7610-95D6-24DC-ACD0-83AC6EC7A69F}"/>
-              </a:ext>
-            </a:extLst>
-          </p:cNvPr>
-          <p:cNvSpPr/>
-          <p:nvPr/>
-        </p:nvSpPr>
-        <p:spPr>
-          <a:xfrm>
-            <a:off x="5861197" y="2602141"/>
-            <a:ext cx="261985" cy="1743759"/>
-          </a:xfrm>
-          <a:prstGeom prst="leftBrace">
-            <a:avLst/>
-          </a:prstGeom>
-          <a:ln>
-            <a:solidFill>
-              <a:schemeClr val="tx1"/>
-            </a:solidFill>
-          </a:ln>
-        </p:spPr>
-        <p:style>
-          <a:lnRef idx="2">
-            <a:schemeClr val="accent1"/>
-          </a:lnRef>
-          <a:fillRef idx="0">
-            <a:schemeClr val="accent1"/>
-          </a:fillRef>
-          <a:effectRef idx="1">
-            <a:schemeClr val="accent1"/>
-          </a:effectRef>
-          <a:fontRef idx="minor">
-            <a:schemeClr val="tx1"/>
-          </a:fontRef>
-        </p:style>
-        <p:txBody>
-          <a:bodyPr rtlCol="0" anchor="ctr"/>
-          <a:lstStyle/>
-          <a:p>
-            <a:pPr algn="ctr"/>
-            <a:endParaRPr lang="en-US"/>
-          </a:p>
-        </p:txBody>
-      </p:sp>
-      <p:cxnSp>
-        <p:nvCxnSpPr>
-          <p:cNvPr id="39" name="Connector: Elbow 38">
-            <a:extLst>
-              <a:ext uri="{FF2B5EF4-FFF2-40B4-BE49-F238E27FC236}">
-                <a16:creationId xmlns:a16="http://schemas.microsoft.com/office/drawing/2014/main" id="{5F33F23B-40EC-FD2A-E9EC-7173483CBF7F}"/>
-              </a:ext>
-            </a:extLst>
-          </p:cNvPr>
-          <p:cNvCxnSpPr>
-            <a:cxnSpLocks/>
-            <a:stCxn id="34" idx="1"/>
-            <a:endCxn id="22" idx="2"/>
-          </p:cNvCxnSpPr>
-          <p:nvPr/>
-        </p:nvCxnSpPr>
-        <p:spPr>
-          <a:xfrm rot="10800000" flipH="1">
-            <a:off x="7440329" y="2637245"/>
-            <a:ext cx="152292" cy="850265"/>
-          </a:xfrm>
-          <a:prstGeom prst="bentConnector5">
-            <a:avLst>
-              <a:gd name="adj1" fmla="val -8339"/>
-              <a:gd name="adj2" fmla="val 99928"/>
-              <a:gd name="adj3" fmla="val 31880"/>
-            </a:avLst>
-          </a:prstGeom>
-          <a:ln>
-            <a:tailEnd type="triangle"/>
-          </a:ln>
-        </p:spPr>
-        <p:style>
-          <a:lnRef idx="2">
-            <a:schemeClr val="dk1"/>
-          </a:lnRef>
-          <a:fillRef idx="0">
-            <a:schemeClr val="dk1"/>
-          </a:fillRef>
-          <a:effectRef idx="1">
-            <a:schemeClr val="dk1"/>
-          </a:effectRef>
-          <a:fontRef idx="minor">
-            <a:schemeClr val="tx1"/>
-          </a:fontRef>
-        </p:style>
       </p:cxnSp>
-      <p:cxnSp>
-        <p:nvCxnSpPr>
-          <p:cNvPr id="66" name="Straight Arrow Connector 65">
-            <a:extLst>
-              <a:ext uri="{FF2B5EF4-FFF2-40B4-BE49-F238E27FC236}">
-                <a16:creationId xmlns:a16="http://schemas.microsoft.com/office/drawing/2014/main" id="{CC1CC510-2C9B-F83B-8358-F0FB9020A8DD}"/>
-              </a:ext>
-            </a:extLst>
-          </p:cNvPr>
-          <p:cNvCxnSpPr>
-            <a:cxnSpLocks/>
-            <a:stCxn id="24" idx="7"/>
-            <a:endCxn id="29" idx="3"/>
-          </p:cNvCxnSpPr>
-          <p:nvPr/>
-        </p:nvCxnSpPr>
-        <p:spPr>
-          <a:xfrm flipV="1">
-            <a:off x="8843975" y="3066520"/>
-            <a:ext cx="490247" cy="578188"/>
-          </a:xfrm>
-          <a:prstGeom prst="straightConnector1">
-            <a:avLst/>
-          </a:prstGeom>
-          <a:ln>
-            <a:tailEnd type="triangle"/>
-          </a:ln>
-        </p:spPr>
-        <p:style>
-          <a:lnRef idx="2">
-            <a:schemeClr val="dk1"/>
-          </a:lnRef>
-          <a:fillRef idx="0">
-            <a:schemeClr val="dk1"/>
-          </a:fillRef>
-          <a:effectRef idx="1">
-            <a:schemeClr val="dk1"/>
-          </a:effectRef>
-          <a:fontRef idx="minor">
-            <a:schemeClr val="tx1"/>
-          </a:fontRef>
-        </p:style>
-      </p:cxnSp>
-      <p:cxnSp>
-        <p:nvCxnSpPr>
-          <p:cNvPr id="72" name="Straight Arrow Connector 71">
-            <a:extLst>
-              <a:ext uri="{FF2B5EF4-FFF2-40B4-BE49-F238E27FC236}">
-                <a16:creationId xmlns:a16="http://schemas.microsoft.com/office/drawing/2014/main" id="{E12571A0-DF1C-4402-4F72-B913EDECAB50}"/>
-              </a:ext>
-            </a:extLst>
-          </p:cNvPr>
-          <p:cNvCxnSpPr>
-            <a:cxnSpLocks/>
-            <a:stCxn id="28" idx="7"/>
-            <a:endCxn id="31" idx="3"/>
-          </p:cNvCxnSpPr>
-          <p:nvPr/>
-        </p:nvCxnSpPr>
-        <p:spPr>
-          <a:xfrm flipV="1">
-            <a:off x="10370878" y="3066520"/>
-            <a:ext cx="507339" cy="578188"/>
-          </a:xfrm>
-          <a:prstGeom prst="straightConnector1">
-            <a:avLst/>
-          </a:prstGeom>
-          <a:ln>
-            <a:tailEnd type="triangle"/>
-          </a:ln>
-        </p:spPr>
-        <p:style>
-          <a:lnRef idx="2">
-            <a:schemeClr val="dk1"/>
-          </a:lnRef>
-          <a:fillRef idx="0">
-            <a:schemeClr val="dk1"/>
-          </a:fillRef>
-          <a:effectRef idx="1">
-            <a:schemeClr val="dk1"/>
-          </a:effectRef>
-          <a:fontRef idx="minor">
-            <a:schemeClr val="tx1"/>
-          </a:fontRef>
-        </p:style>
-      </p:cxnSp>
-      <p:sp>
-        <p:nvSpPr>
-          <p:cNvPr id="76" name="TextBox 75">
-            <a:extLst>
-              <a:ext uri="{FF2B5EF4-FFF2-40B4-BE49-F238E27FC236}">
-                <a16:creationId xmlns:a16="http://schemas.microsoft.com/office/drawing/2014/main" id="{1BD7F705-5094-7323-A27D-4B4E929E3148}"/>
-              </a:ext>
-            </a:extLst>
-          </p:cNvPr>
-          <p:cNvSpPr txBox="1"/>
-          <p:nvPr/>
-        </p:nvSpPr>
-        <p:spPr>
-          <a:xfrm>
-            <a:off x="5953159" y="4387934"/>
-            <a:ext cx="1459054" cy="769441"/>
-          </a:xfrm>
-          <a:prstGeom prst="rect">
-            <a:avLst/>
-          </a:prstGeom>
-          <a:noFill/>
-        </p:spPr>
-        <p:txBody>
-          <a:bodyPr wrap="none" rtlCol="0">
-            <a:spAutoFit/>
-          </a:bodyPr>
-          <a:lstStyle/>
-          <a:p>
-            <a:r>
-              <a:rPr lang="en-US" sz="1100" dirty="0"/>
-              <a:t>The tool deliberation</a:t>
-            </a:r>
-          </a:p>
-          <a:p>
-            <a:r>
-              <a:rPr lang="en-US" sz="1100" dirty="0"/>
-              <a:t>stage decides all the </a:t>
-            </a:r>
-          </a:p>
-          <a:p>
-            <a:r>
-              <a:rPr lang="en-US" sz="1100" dirty="0"/>
-              <a:t>tools it should call in</a:t>
-            </a:r>
-          </a:p>
-          <a:p>
-            <a:r>
-              <a:rPr lang="en-US" sz="1100" dirty="0"/>
-              <a:t>a single step</a:t>
-            </a:r>
-          </a:p>
-        </p:txBody>
-      </p:sp>
     </p:spTree>
     <p:extLst>
       <p:ext uri="{BB962C8B-B14F-4D97-AF65-F5344CB8AC3E}">

</xml_diff>

<commit_message>
Adds support for asking about diseases
Adds support for asking about diseases
</commit_message>
<xml_diff>
--- a/graph_architecture.pptx
+++ b/graph_architecture.pptx
@@ -6,6 +6,8 @@
   </p:sldMasterIdLst>
   <p:sldIdLst>
     <p:sldId id="256" r:id="rId2"/>
+    <p:sldId id="257" r:id="rId3"/>
+    <p:sldId id="258" r:id="rId4"/>
   </p:sldIdLst>
   <p:sldSz cx="12192000" cy="6858000"/>
   <p:notesSz cx="6858000" cy="9144000"/>
@@ -259,7 +261,7 @@
           <a:p>
             <a:fld id="{2D8659F3-DB80-4E75-82CE-949E02E89EB1}" type="datetimeFigureOut">
               <a:rPr lang="en-US" smtClean="0"/>
-              <a:t>4/30/2025</a:t>
+              <a:t>5/7/2025</a:t>
             </a:fld>
             <a:endParaRPr lang="en-US"/>
           </a:p>
@@ -457,7 +459,7 @@
           <a:p>
             <a:fld id="{2D8659F3-DB80-4E75-82CE-949E02E89EB1}" type="datetimeFigureOut">
               <a:rPr lang="en-US" smtClean="0"/>
-              <a:t>4/30/2025</a:t>
+              <a:t>5/7/2025</a:t>
             </a:fld>
             <a:endParaRPr lang="en-US"/>
           </a:p>
@@ -665,7 +667,7 @@
           <a:p>
             <a:fld id="{2D8659F3-DB80-4E75-82CE-949E02E89EB1}" type="datetimeFigureOut">
               <a:rPr lang="en-US" smtClean="0"/>
-              <a:t>4/30/2025</a:t>
+              <a:t>5/7/2025</a:t>
             </a:fld>
             <a:endParaRPr lang="en-US"/>
           </a:p>
@@ -863,7 +865,7 @@
           <a:p>
             <a:fld id="{2D8659F3-DB80-4E75-82CE-949E02E89EB1}" type="datetimeFigureOut">
               <a:rPr lang="en-US" smtClean="0"/>
-              <a:t>4/30/2025</a:t>
+              <a:t>5/7/2025</a:t>
             </a:fld>
             <a:endParaRPr lang="en-US"/>
           </a:p>
@@ -1138,7 +1140,7 @@
           <a:p>
             <a:fld id="{2D8659F3-DB80-4E75-82CE-949E02E89EB1}" type="datetimeFigureOut">
               <a:rPr lang="en-US" smtClean="0"/>
-              <a:t>4/30/2025</a:t>
+              <a:t>5/7/2025</a:t>
             </a:fld>
             <a:endParaRPr lang="en-US"/>
           </a:p>
@@ -1403,7 +1405,7 @@
           <a:p>
             <a:fld id="{2D8659F3-DB80-4E75-82CE-949E02E89EB1}" type="datetimeFigureOut">
               <a:rPr lang="en-US" smtClean="0"/>
-              <a:t>4/30/2025</a:t>
+              <a:t>5/7/2025</a:t>
             </a:fld>
             <a:endParaRPr lang="en-US"/>
           </a:p>
@@ -1815,7 +1817,7 @@
           <a:p>
             <a:fld id="{2D8659F3-DB80-4E75-82CE-949E02E89EB1}" type="datetimeFigureOut">
               <a:rPr lang="en-US" smtClean="0"/>
-              <a:t>4/30/2025</a:t>
+              <a:t>5/7/2025</a:t>
             </a:fld>
             <a:endParaRPr lang="en-US"/>
           </a:p>
@@ -1956,7 +1958,7 @@
           <a:p>
             <a:fld id="{2D8659F3-DB80-4E75-82CE-949E02E89EB1}" type="datetimeFigureOut">
               <a:rPr lang="en-US" smtClean="0"/>
-              <a:t>4/30/2025</a:t>
+              <a:t>5/7/2025</a:t>
             </a:fld>
             <a:endParaRPr lang="en-US"/>
           </a:p>
@@ -2069,7 +2071,7 @@
           <a:p>
             <a:fld id="{2D8659F3-DB80-4E75-82CE-949E02E89EB1}" type="datetimeFigureOut">
               <a:rPr lang="en-US" smtClean="0"/>
-              <a:t>4/30/2025</a:t>
+              <a:t>5/7/2025</a:t>
             </a:fld>
             <a:endParaRPr lang="en-US"/>
           </a:p>
@@ -2380,7 +2382,7 @@
           <a:p>
             <a:fld id="{2D8659F3-DB80-4E75-82CE-949E02E89EB1}" type="datetimeFigureOut">
               <a:rPr lang="en-US" smtClean="0"/>
-              <a:t>4/30/2025</a:t>
+              <a:t>5/7/2025</a:t>
             </a:fld>
             <a:endParaRPr lang="en-US"/>
           </a:p>
@@ -2668,7 +2670,7 @@
           <a:p>
             <a:fld id="{2D8659F3-DB80-4E75-82CE-949E02E89EB1}" type="datetimeFigureOut">
               <a:rPr lang="en-US" smtClean="0"/>
-              <a:t>4/30/2025</a:t>
+              <a:t>5/7/2025</a:t>
             </a:fld>
             <a:endParaRPr lang="en-US"/>
           </a:p>
@@ -2909,7 +2911,7 @@
           <a:p>
             <a:fld id="{2D8659F3-DB80-4E75-82CE-949E02E89EB1}" type="datetimeFigureOut">
               <a:rPr lang="en-US" smtClean="0"/>
-              <a:t>4/30/2025</a:t>
+              <a:t>5/7/2025</a:t>
             </a:fld>
             <a:endParaRPr lang="en-US"/>
           </a:p>
@@ -5458,6 +5460,390 @@
     <p:extLst>
       <p:ext uri="{BB962C8B-B14F-4D97-AF65-F5344CB8AC3E}">
         <p14:creationId xmlns:p14="http://schemas.microsoft.com/office/powerpoint/2010/main" val="3805428150"/>
+      </p:ext>
+    </p:extLst>
+  </p:cSld>
+  <p:clrMapOvr>
+    <a:masterClrMapping/>
+  </p:clrMapOvr>
+</p:sld>
+</file>
+
+<file path=ppt/slides/slide2.xml><?xml version="1.0" encoding="utf-8"?>
+<p:sld xmlns:a="http://schemas.openxmlformats.org/drawingml/2006/main" xmlns:r="http://schemas.openxmlformats.org/officeDocument/2006/relationships" xmlns:p="http://schemas.openxmlformats.org/presentationml/2006/main">
+  <p:cSld>
+    <p:spTree>
+      <p:nvGrpSpPr>
+        <p:cNvPr id="1" name=""/>
+        <p:cNvGrpSpPr/>
+        <p:nvPr/>
+      </p:nvGrpSpPr>
+      <p:grpSpPr>
+        <a:xfrm>
+          <a:off x="0" y="0"/>
+          <a:ext cx="0" cy="0"/>
+          <a:chOff x="0" y="0"/>
+          <a:chExt cx="0" cy="0"/>
+        </a:xfrm>
+      </p:grpSpPr>
+      <p:sp>
+        <p:nvSpPr>
+          <p:cNvPr id="3" name="Content Placeholder 2">
+            <a:extLst>
+              <a:ext uri="{FF2B5EF4-FFF2-40B4-BE49-F238E27FC236}">
+                <a16:creationId xmlns:a16="http://schemas.microsoft.com/office/drawing/2014/main" id="{A02C34BE-9A86-8132-6373-46BEE2439DA4}"/>
+              </a:ext>
+            </a:extLst>
+          </p:cNvPr>
+          <p:cNvSpPr>
+            <a:spLocks noGrp="1"/>
+          </p:cNvSpPr>
+          <p:nvPr>
+            <p:ph idx="1"/>
+          </p:nvPr>
+        </p:nvSpPr>
+        <p:spPr>
+          <a:xfrm>
+            <a:off x="49427" y="74141"/>
+            <a:ext cx="11973697" cy="6864178"/>
+          </a:xfrm>
+        </p:spPr>
+        <p:txBody>
+          <a:bodyPr>
+            <a:normAutofit lnSpcReduction="10000"/>
+          </a:bodyPr>
+          <a:lstStyle/>
+          <a:p>
+            <a:r>
+              <a:rPr lang="en-US" sz="1100" b="1" dirty="0"/>
+              <a:t>The </a:t>
+            </a:r>
+            <a:r>
+              <a:rPr lang="en-US" sz="1100" b="1" dirty="0" err="1"/>
+              <a:t>ToxPipe</a:t>
+            </a:r>
+            <a:r>
+              <a:rPr lang="en-US" sz="1100" b="1" dirty="0"/>
+              <a:t> agent is specifically designed to provided information when given specific chemical identifiers</a:t>
+            </a:r>
+          </a:p>
+          <a:p>
+            <a:r>
+              <a:rPr lang="en-US" sz="1100" dirty="0"/>
+              <a:t>Context/memory management</a:t>
+            </a:r>
+          </a:p>
+          <a:p>
+            <a:pPr lvl="1"/>
+            <a:r>
+              <a:rPr lang="en-US" sz="1000" dirty="0"/>
+              <a:t>Size (# tokens) – minorly affects speed, ability to recall</a:t>
+            </a:r>
+          </a:p>
+          <a:p>
+            <a:pPr lvl="2"/>
+            <a:r>
+              <a:rPr lang="en-US" sz="900" dirty="0"/>
+              <a:t>Gets confused when abruptly switching subjects</a:t>
+            </a:r>
+          </a:p>
+          <a:p>
+            <a:pPr lvl="1"/>
+            <a:r>
+              <a:rPr lang="en-US" sz="1000" dirty="0"/>
+              <a:t>When to prune?</a:t>
+            </a:r>
+          </a:p>
+          <a:p>
+            <a:pPr lvl="1"/>
+            <a:r>
+              <a:rPr lang="en-US" sz="1000" dirty="0"/>
+              <a:t>Consider when making repeated calls to a single agent</a:t>
+            </a:r>
+          </a:p>
+          <a:p>
+            <a:pPr lvl="1"/>
+            <a:r>
+              <a:rPr lang="en-US" sz="1000" dirty="0"/>
+              <a:t>Caching</a:t>
+            </a:r>
+          </a:p>
+          <a:p>
+            <a:pPr lvl="2"/>
+            <a:r>
+              <a:rPr lang="en-US" sz="900" dirty="0"/>
+              <a:t>Use memory/context to avoid making same calls repeatedly</a:t>
+            </a:r>
+          </a:p>
+          <a:p>
+            <a:r>
+              <a:rPr lang="en-US" sz="1100" dirty="0"/>
+              <a:t>Runtime</a:t>
+            </a:r>
+          </a:p>
+          <a:p>
+            <a:pPr lvl="1"/>
+            <a:r>
+              <a:rPr lang="en-US" sz="1000" dirty="0"/>
+              <a:t>Biggest factor – num. of output tokens – smaller response = faster </a:t>
+            </a:r>
+          </a:p>
+          <a:p>
+            <a:pPr lvl="1"/>
+            <a:r>
+              <a:rPr lang="en-US" sz="1000" dirty="0"/>
+              <a:t>Parallelization</a:t>
+            </a:r>
+          </a:p>
+          <a:p>
+            <a:pPr lvl="2"/>
+            <a:r>
+              <a:rPr lang="en-US" sz="900" dirty="0"/>
+              <a:t>Perform tool use/rag search/lit. search simultaneously to save time</a:t>
+            </a:r>
+          </a:p>
+          <a:p>
+            <a:r>
+              <a:rPr lang="en-US" sz="1100" dirty="0"/>
+              <a:t>When is it appropriate to use graph-based agents?</a:t>
+            </a:r>
+          </a:p>
+          <a:p>
+            <a:pPr lvl="1"/>
+            <a:r>
+              <a:rPr lang="en-US" sz="1000" dirty="0"/>
+              <a:t>Like a Google search – broad question, defined ways to get there</a:t>
+            </a:r>
+          </a:p>
+          <a:p>
+            <a:pPr lvl="2"/>
+            <a:r>
+              <a:rPr lang="en-US" sz="900" dirty="0"/>
+              <a:t>Defined use cases / “trains of thought” – specific tools in mind</a:t>
+            </a:r>
+          </a:p>
+          <a:p>
+            <a:pPr lvl="2"/>
+            <a:r>
+              <a:rPr lang="en-US" sz="900" dirty="0"/>
+              <a:t>Multiple choices/tools to pick</a:t>
+            </a:r>
+          </a:p>
+          <a:p>
+            <a:pPr lvl="2"/>
+            <a:r>
+              <a:rPr lang="en-US" sz="900" dirty="0"/>
+              <a:t>Need to hardcode these paths</a:t>
+            </a:r>
+          </a:p>
+          <a:p>
+            <a:pPr lvl="2"/>
+            <a:r>
+              <a:rPr lang="en-US" sz="900" dirty="0"/>
+              <a:t>i.e., “What is the function of Aspirin?”</a:t>
+            </a:r>
+          </a:p>
+          <a:p>
+            <a:pPr lvl="3"/>
+            <a:r>
+              <a:rPr lang="en-US" sz="800" dirty="0"/>
+              <a:t>Targets, interactions, diseases, usage in products, genes, etc.</a:t>
+            </a:r>
+          </a:p>
+          <a:p>
+            <a:pPr lvl="1"/>
+            <a:r>
+              <a:rPr lang="en-US" sz="1000" dirty="0"/>
+              <a:t>Complex queries that require multiple parts</a:t>
+            </a:r>
+          </a:p>
+          <a:p>
+            <a:pPr lvl="1"/>
+            <a:r>
+              <a:rPr lang="en-US" sz="1000" dirty="0"/>
+              <a:t>When you need to explicitly make the agent perform certain tasks in a certain order – high level of config/control over agent behavior</a:t>
+            </a:r>
+          </a:p>
+          <a:p>
+            <a:r>
+              <a:rPr lang="en-US" sz="1100" dirty="0"/>
+              <a:t>Transparency, reliability, and reproducibility</a:t>
+            </a:r>
+          </a:p>
+          <a:p>
+            <a:pPr lvl="1"/>
+            <a:r>
+              <a:rPr lang="en-US" sz="1000" dirty="0"/>
+              <a:t>Include sources for data – easy to do since we can control tool output</a:t>
+            </a:r>
+          </a:p>
+          <a:p>
+            <a:pPr lvl="1"/>
+            <a:r>
+              <a:rPr lang="en-US" sz="1000" dirty="0"/>
+              <a:t>Add stipulation in prompt engineering – could also force inclusion with output parsing</a:t>
+            </a:r>
+          </a:p>
+          <a:p>
+            <a:r>
+              <a:rPr lang="en-US" sz="1100" dirty="0"/>
+              <a:t>Future-proofing</a:t>
+            </a:r>
+          </a:p>
+          <a:p>
+            <a:pPr lvl="1"/>
+            <a:r>
+              <a:rPr lang="en-US" sz="1000" dirty="0"/>
+              <a:t>Tools are useful for adding new functionality w/o needing to retrain/build models</a:t>
+            </a:r>
+          </a:p>
+          <a:p>
+            <a:pPr lvl="1"/>
+            <a:r>
+              <a:rPr lang="en-US" sz="1000" dirty="0"/>
+              <a:t>RAG search database can be appended to with new documents</a:t>
+            </a:r>
+          </a:p>
+          <a:p>
+            <a:r>
+              <a:rPr lang="en-US" sz="1100" dirty="0"/>
+              <a:t>API limitations</a:t>
+            </a:r>
+          </a:p>
+          <a:p>
+            <a:pPr lvl="1"/>
+            <a:r>
+              <a:rPr lang="en-US" sz="1000" dirty="0"/>
+              <a:t>Accessing PubMed – rate limit, large # files takes longer</a:t>
+            </a:r>
+          </a:p>
+          <a:p>
+            <a:r>
+              <a:rPr lang="en-US" sz="1100" dirty="0"/>
+              <a:t>Tool selection</a:t>
+            </a:r>
+          </a:p>
+          <a:p>
+            <a:pPr lvl="1"/>
+            <a:r>
+              <a:rPr lang="en-US" sz="1000" dirty="0"/>
+              <a:t>GPT-4o can make multiple tool calls in a single stage, so only need to do one deliberation stage</a:t>
+            </a:r>
+          </a:p>
+          <a:p>
+            <a:pPr lvl="1"/>
+            <a:r>
+              <a:rPr lang="en-US" sz="1000" dirty="0"/>
+              <a:t>Standardize tool input to avoid errors</a:t>
+            </a:r>
+          </a:p>
+          <a:p>
+            <a:pPr lvl="1"/>
+            <a:r>
+              <a:rPr lang="en-US" sz="1000" dirty="0"/>
+              <a:t>Prompt engineering</a:t>
+            </a:r>
+          </a:p>
+          <a:p>
+            <a:pPr lvl="2"/>
+            <a:r>
+              <a:rPr lang="en-US" sz="1000" dirty="0"/>
+              <a:t>Improve tool descriptions to be more informative of when to use a given tool</a:t>
+            </a:r>
+            <a:endParaRPr lang="en-US" sz="1100" dirty="0"/>
+          </a:p>
+          <a:p>
+            <a:pPr marL="0" indent="0">
+              <a:buNone/>
+            </a:pPr>
+            <a:endParaRPr lang="en-US" sz="1100" dirty="0"/>
+          </a:p>
+        </p:txBody>
+      </p:sp>
+    </p:spTree>
+    <p:extLst>
+      <p:ext uri="{BB962C8B-B14F-4D97-AF65-F5344CB8AC3E}">
+        <p14:creationId xmlns:p14="http://schemas.microsoft.com/office/powerpoint/2010/main" val="3648106056"/>
+      </p:ext>
+    </p:extLst>
+  </p:cSld>
+  <p:clrMapOvr>
+    <a:masterClrMapping/>
+  </p:clrMapOvr>
+</p:sld>
+</file>
+
+<file path=ppt/slides/slide3.xml><?xml version="1.0" encoding="utf-8"?>
+<p:sld xmlns:a="http://schemas.openxmlformats.org/drawingml/2006/main" xmlns:r="http://schemas.openxmlformats.org/officeDocument/2006/relationships" xmlns:p="http://schemas.openxmlformats.org/presentationml/2006/main">
+  <p:cSld>
+    <p:spTree>
+      <p:nvGrpSpPr>
+        <p:cNvPr id="1" name=""/>
+        <p:cNvGrpSpPr/>
+        <p:nvPr/>
+      </p:nvGrpSpPr>
+      <p:grpSpPr>
+        <a:xfrm>
+          <a:off x="0" y="0"/>
+          <a:ext cx="0" cy="0"/>
+          <a:chOff x="0" y="0"/>
+          <a:chExt cx="0" cy="0"/>
+        </a:xfrm>
+      </p:grpSpPr>
+      <p:sp>
+        <p:nvSpPr>
+          <p:cNvPr id="2" name="Title 1">
+            <a:extLst>
+              <a:ext uri="{FF2B5EF4-FFF2-40B4-BE49-F238E27FC236}">
+                <a16:creationId xmlns:a16="http://schemas.microsoft.com/office/drawing/2014/main" id="{AE8D1346-3915-9F89-6CD5-80FBBE4A08CF}"/>
+              </a:ext>
+            </a:extLst>
+          </p:cNvPr>
+          <p:cNvSpPr>
+            <a:spLocks noGrp="1"/>
+          </p:cNvSpPr>
+          <p:nvPr>
+            <p:ph type="title"/>
+          </p:nvPr>
+        </p:nvSpPr>
+        <p:spPr/>
+        <p:txBody>
+          <a:bodyPr/>
+          <a:lstStyle/>
+          <a:p>
+            <a:endParaRPr lang="en-US"/>
+          </a:p>
+        </p:txBody>
+      </p:sp>
+      <p:sp>
+        <p:nvSpPr>
+          <p:cNvPr id="3" name="Content Placeholder 2">
+            <a:extLst>
+              <a:ext uri="{FF2B5EF4-FFF2-40B4-BE49-F238E27FC236}">
+                <a16:creationId xmlns:a16="http://schemas.microsoft.com/office/drawing/2014/main" id="{3D3C755F-4147-2899-239F-7BD0BAAF67E2}"/>
+              </a:ext>
+            </a:extLst>
+          </p:cNvPr>
+          <p:cNvSpPr>
+            <a:spLocks noGrp="1"/>
+          </p:cNvSpPr>
+          <p:nvPr>
+            <p:ph idx="1"/>
+          </p:nvPr>
+        </p:nvSpPr>
+        <p:spPr/>
+        <p:txBody>
+          <a:bodyPr/>
+          <a:lstStyle/>
+          <a:p>
+            <a:endParaRPr lang="en-US"/>
+          </a:p>
+        </p:txBody>
+      </p:sp>
+    </p:spTree>
+    <p:extLst>
+      <p:ext uri="{BB962C8B-B14F-4D97-AF65-F5344CB8AC3E}">
+        <p14:creationId xmlns:p14="http://schemas.microsoft.com/office/powerpoint/2010/main" val="3306822033"/>
       </p:ext>
     </p:extLst>
   </p:cSld>

</xml_diff>